<commit_message>
docs: enhance AGENTS.md with lab details and update RAG context modes
Add a section in AGENTS.md for the reproducible lab setup, detailing PostgreSQL, pgvector, and the evaluation process. Update the descriptions of RAG_CONTEXT_MODE settings in the README and wrangler.jsonc to clarify their roles in the course. Modify the demo and lab README files to reflect the new structure and content. Adjust TypeScript configurations to include lab files and ensure compatibility with the new setup.

Co-Authored-By: Claude <noreply@anthropic.com>
</commit_message>
<xml_diff>
--- a/material/presentaciones/S10-rag-basico.pptx
+++ b/material/presentaciones/S10-rag-basico.pptx
@@ -765,131 +765,131 @@
             </a:pPr>
             <a:r>
               <a:rPr lang="en-US"/>
-              <a:t>S10 · 01/15 · 18:30. Objetivo del producto.</a:t>
-            </a:r>
-            <a:endParaRPr/>
-          </a:p>
-          <a:p>
-            <a:pPr indent="0" lvl="0" marL="0" rtl="0" algn="l">
-              <a:spcBef>
-                <a:spcPts val="0"/>
-              </a:spcBef>
-              <a:spcAft>
-                <a:spcPts val="0"/>
-              </a:spcAft>
-              <a:buNone/>
-            </a:pPr>
-            <a:r>
-              <a:t/>
-            </a:r>
-            <a:endParaRPr/>
-          </a:p>
-          <a:p>
-            <a:pPr indent="0" lvl="0" marL="0" rtl="0" algn="l">
-              <a:spcBef>
-                <a:spcPts val="0"/>
-              </a:spcBef>
-              <a:spcAft>
-                <a:spcPts val="0"/>
-              </a:spcAft>
-              <a:buNone/>
-            </a:pPr>
-            <a:r>
-              <a:rPr lang="en-US"/>
-              <a:t>Di: el asistente cubre S1 a S20 y a todos los profesores. No es una empresa ficticia ni solo mis clases.</a:t>
-            </a:r>
-            <a:endParaRPr/>
-          </a:p>
-          <a:p>
-            <a:pPr indent="0" lvl="0" marL="0" rtl="0" algn="l">
-              <a:spcBef>
-                <a:spcPts val="0"/>
-              </a:spcBef>
-              <a:spcAft>
-                <a:spcPts val="0"/>
-              </a:spcAft>
-              <a:buNone/>
-            </a:pPr>
-            <a:r>
-              <a:t/>
-            </a:r>
-            <a:endParaRPr/>
-          </a:p>
-          <a:p>
-            <a:pPr indent="0" lvl="0" marL="0" rtl="0" algn="l">
-              <a:spcBef>
-                <a:spcPts val="0"/>
-              </a:spcBef>
-              <a:spcAft>
-                <a:spcPts val="0"/>
-              </a:spcAft>
-              <a:buNone/>
-            </a:pPr>
-            <a:r>
-              <a:rPr lang="en-US"/>
-              <a:t>Señala el diagrama: preguntar, recuperar, citar o rechazar. La app ya está construida; hoy no instalamos el monorepo.</a:t>
-            </a:r>
-            <a:endParaRPr/>
-          </a:p>
-          <a:p>
-            <a:pPr indent="0" lvl="0" marL="0" rtl="0" algn="l">
-              <a:spcBef>
-                <a:spcPts val="0"/>
-              </a:spcBef>
-              <a:spcAft>
-                <a:spcPts val="0"/>
-              </a:spcAft>
-              <a:buNone/>
-            </a:pPr>
-            <a:r>
-              <a:t/>
-            </a:r>
-            <a:endParaRPr/>
-          </a:p>
-          <a:p>
-            <a:pPr indent="0" lvl="0" marL="0" rtl="0" algn="l">
-              <a:spcBef>
-                <a:spcPts val="0"/>
-              </a:spcBef>
-              <a:spcAft>
-                <a:spcPts val="0"/>
-              </a:spcAft>
-              <a:buNone/>
-            </a:pPr>
-            <a:r>
-              <a:rPr lang="en-US"/>
-              <a:t>Abre la diapositiva, no el terminal.</a:t>
-            </a:r>
-            <a:endParaRPr/>
-          </a:p>
-          <a:p>
-            <a:pPr indent="0" lvl="0" marL="0" rtl="0" algn="l">
-              <a:spcBef>
-                <a:spcPts val="0"/>
-              </a:spcBef>
-              <a:spcAft>
-                <a:spcPts val="0"/>
-              </a:spcAft>
-              <a:buNone/>
-            </a:pPr>
-            <a:r>
-              <a:t/>
-            </a:r>
-            <a:endParaRPr/>
-          </a:p>
-          <a:p>
-            <a:pPr indent="0" lvl="0" marL="0" rtl="0" algn="l">
-              <a:spcBef>
-                <a:spcPts val="0"/>
-              </a:spcBef>
-              <a:spcAft>
-                <a:spcPts val="0"/>
-              </a:spcAft>
-              <a:buNone/>
-            </a:pPr>
-            <a:r>
-              <a:rPr lang="en-US"/>
-              <a:t>Adaptación autorizada para esta demo: Vectorize, D1 y R2. S9 sigue enseñando PostgreSQL y pgvector.</a:t>
+              <a:t>S10 · 01/15 · 18:30. Objetivo de la sesión. Presenta el recorrido principal: construir un RAG semántico completo (fragmentación con solapamiento, embeddings, índice vectorial, umbral previo a generar, citas y rechazo) y su laboratorio reproducible en PostgreSQL + pgvector (vector(768) + HNSW) en lab/, acompañado del demostrador del curso AI Engineer en Cloudflare (BGE-M3 1024 d, claude-haiku-5-5).</a:t>
+            </a:r>
+            <a:endParaRPr/>
+          </a:p>
+          <a:p>
+            <a:pPr indent="0" lvl="0" marL="0" rtl="0" algn="l">
+              <a:spcBef>
+                <a:spcPts val="0"/>
+              </a:spcBef>
+              <a:spcAft>
+                <a:spcPts val="0"/>
+              </a:spcAft>
+              <a:buNone/>
+            </a:pPr>
+            <a:r>
+              <a:t/>
+            </a:r>
+            <a:endParaRPr/>
+          </a:p>
+          <a:p>
+            <a:pPr indent="0" lvl="0" marL="0" rtl="0" algn="l">
+              <a:spcBef>
+                <a:spcPts val="0"/>
+              </a:spcBef>
+              <a:spcAft>
+                <a:spcPts val="0"/>
+              </a:spcAft>
+              <a:buNone/>
+            </a:pPr>
+            <a:r>
+              <a:rPr lang="en-US"/>
+              <a:t/>
+            </a:r>
+            <a:endParaRPr/>
+          </a:p>
+          <a:p>
+            <a:pPr indent="0" lvl="0" marL="0" rtl="0" algn="l">
+              <a:spcBef>
+                <a:spcPts val="0"/>
+              </a:spcBef>
+              <a:spcAft>
+                <a:spcPts val="0"/>
+              </a:spcAft>
+              <a:buNone/>
+            </a:pPr>
+            <a:r>
+              <a:t/>
+            </a:r>
+            <a:endParaRPr/>
+          </a:p>
+          <a:p>
+            <a:pPr indent="0" lvl="0" marL="0" rtl="0" algn="l">
+              <a:spcBef>
+                <a:spcPts val="0"/>
+              </a:spcBef>
+              <a:spcAft>
+                <a:spcPts val="0"/>
+              </a:spcAft>
+              <a:buNone/>
+            </a:pPr>
+            <a:r>
+              <a:rPr lang="en-US"/>
+              <a:t/>
+            </a:r>
+            <a:endParaRPr/>
+          </a:p>
+          <a:p>
+            <a:pPr indent="0" lvl="0" marL="0" rtl="0" algn="l">
+              <a:spcBef>
+                <a:spcPts val="0"/>
+              </a:spcBef>
+              <a:spcAft>
+                <a:spcPts val="0"/>
+              </a:spcAft>
+              <a:buNone/>
+            </a:pPr>
+            <a:r>
+              <a:t/>
+            </a:r>
+            <a:endParaRPr/>
+          </a:p>
+          <a:p>
+            <a:pPr indent="0" lvl="0" marL="0" rtl="0" algn="l">
+              <a:spcBef>
+                <a:spcPts val="0"/>
+              </a:spcBef>
+              <a:spcAft>
+                <a:spcPts val="0"/>
+              </a:spcAft>
+              <a:buNone/>
+            </a:pPr>
+            <a:r>
+              <a:rPr lang="en-US"/>
+              <a:t/>
+            </a:r>
+            <a:endParaRPr/>
+          </a:p>
+          <a:p>
+            <a:pPr indent="0" lvl="0" marL="0" rtl="0" algn="l">
+              <a:spcBef>
+                <a:spcPts val="0"/>
+              </a:spcBef>
+              <a:spcAft>
+                <a:spcPts val="0"/>
+              </a:spcAft>
+              <a:buNone/>
+            </a:pPr>
+            <a:r>
+              <a:t/>
+            </a:r>
+            <a:endParaRPr/>
+          </a:p>
+          <a:p>
+            <a:pPr indent="0" lvl="0" marL="0" rtl="0" algn="l">
+              <a:spcBef>
+                <a:spcPts val="0"/>
+              </a:spcBef>
+              <a:spcAft>
+                <a:spcPts val="0"/>
+              </a:spcAft>
+              <a:buNone/>
+            </a:pPr>
+            <a:r>
+              <a:rPr lang="en-US"/>
+              <a:t/>
             </a:r>
             <a:endParaRPr/>
           </a:p>
@@ -1425,116 +1425,116 @@
             </a:pPr>
             <a:r>
               <a:rPr lang="en-US"/>
-              <a:t>S10 · 10/15 · bloque 60–75. Rechazo y cohortes.</a:t>
-            </a:r>
-            <a:endParaRPr/>
-          </a:p>
-          <a:p>
-            <a:pPr indent="0" lvl="0" marL="0" rtl="0" algn="l">
-              <a:spcBef>
-                <a:spcPts val="0"/>
-              </a:spcBef>
-              <a:spcAft>
-                <a:spcPts val="0"/>
-              </a:spcAft>
-              <a:buNone/>
-            </a:pPr>
-            <a:r>
-              <a:t/>
-            </a:r>
-            <a:endParaRPr/>
-          </a:p>
-          <a:p>
-            <a:pPr indent="0" lvl="0" marL="0" rtl="0" algn="l">
-              <a:spcBef>
-                <a:spcPts val="0"/>
-              </a:spcBef>
-              <a:spcAft>
-                <a:spcPts val="0"/>
-              </a:spcAft>
-              <a:buNone/>
-            </a:pPr>
-            <a:r>
-              <a:rPr lang="en-US"/>
-              <a:t>Pregunta: ¿Qué beca interna del año 1991 cubre este programa?</a:t>
-            </a:r>
-            <a:endParaRPr/>
-          </a:p>
-          <a:p>
-            <a:pPr indent="0" lvl="0" marL="0" rtl="0" algn="l">
-              <a:spcBef>
-                <a:spcPts val="0"/>
-              </a:spcBef>
-              <a:spcAft>
-                <a:spcPts val="0"/>
-              </a:spcAft>
-              <a:buNone/>
-            </a:pPr>
-            <a:r>
-              <a:t/>
-            </a:r>
-            <a:endParaRPr/>
-          </a:p>
-          <a:p>
-            <a:pPr indent="0" lvl="0" marL="0" rtl="0" algn="l">
-              <a:spcBef>
-                <a:spcPts val="0"/>
-              </a:spcBef>
-              <a:spcAft>
-                <a:spcPts val="0"/>
-              </a:spcAft>
-              <a:buNone/>
-            </a:pPr>
-            <a:r>
-              <a:rPr lang="en-US"/>
-              <a:t>Debe decir que no hay contexto utilizable y no llamar a un modelo.</a:t>
-            </a:r>
-            <a:endParaRPr/>
-          </a:p>
-          <a:p>
-            <a:pPr indent="0" lvl="0" marL="0" rtl="0" algn="l">
-              <a:spcBef>
-                <a:spcPts val="0"/>
-              </a:spcBef>
-              <a:spcAft>
-                <a:spcPts val="0"/>
-              </a:spcAft>
-              <a:buNone/>
-            </a:pPr>
-            <a:r>
-              <a:t/>
-            </a:r>
-            <a:endParaRPr/>
-          </a:p>
-          <a:p>
-            <a:pPr indent="0" lvl="0" marL="0" rtl="0" algn="l">
-              <a:spcBef>
-                <a:spcPts val="0"/>
-              </a:spcBef>
-              <a:spcAft>
-                <a:spcPts val="0"/>
-              </a:spcAft>
-              <a:buNone/>
-            </a:pPr>
-            <a:r>
-              <a:rPr lang="en-US"/>
-              <a:t>Luego audiencia M/J y la fecha de RAG S10: 2026-10-22.</a:t>
-            </a:r>
-            <a:endParaRPr/>
-          </a:p>
-          <a:p>
-            <a:pPr indent="0" lvl="0" marL="0" rtl="0" algn="l">
-              <a:spcBef>
-                <a:spcPts val="0"/>
-              </a:spcBef>
-              <a:spcAft>
-                <a:spcPts val="0"/>
-              </a:spcAft>
-              <a:buNone/>
-            </a:pPr>
-            <a:r>
-              <a:rPr lang="en-US"/>
-              <a:t>No presentes el 0,33 como umbral semántico.</a:t>
+              <a:t>S10 · 10/15 · bloque 60–75 min. Demostración del rechazo previo a la generación: pregunta por la beca interna de 1991 (en el curso) o por licencias de Windows Server 2025 (en lab/). El control de umbral rechaza sin llamar al modelo generativo (generationCalled: false). Muestra también la aclaración de calendario sin cohorte y el filtro entre M/J (22 de octubre) y L/X (26 de octubre).</a:t>
+            </a:r>
+            <a:endParaRPr/>
+          </a:p>
+          <a:p>
+            <a:pPr indent="0" lvl="0" marL="0" rtl="0" algn="l">
+              <a:spcBef>
+                <a:spcPts val="0"/>
+              </a:spcBef>
+              <a:spcAft>
+                <a:spcPts val="0"/>
+              </a:spcAft>
+              <a:buNone/>
+            </a:pPr>
+            <a:r>
+              <a:t/>
+            </a:r>
+            <a:endParaRPr/>
+          </a:p>
+          <a:p>
+            <a:pPr indent="0" lvl="0" marL="0" rtl="0" algn="l">
+              <a:spcBef>
+                <a:spcPts val="0"/>
+              </a:spcBef>
+              <a:spcAft>
+                <a:spcPts val="0"/>
+              </a:spcAft>
+              <a:buNone/>
+            </a:pPr>
+            <a:r>
+              <a:rPr lang="en-US"/>
+              <a:t/>
+            </a:r>
+            <a:endParaRPr/>
+          </a:p>
+          <a:p>
+            <a:pPr indent="0" lvl="0" marL="0" rtl="0" algn="l">
+              <a:spcBef>
+                <a:spcPts val="0"/>
+              </a:spcBef>
+              <a:spcAft>
+                <a:spcPts val="0"/>
+              </a:spcAft>
+              <a:buNone/>
+            </a:pPr>
+            <a:r>
+              <a:t/>
+            </a:r>
+            <a:endParaRPr/>
+          </a:p>
+          <a:p>
+            <a:pPr indent="0" lvl="0" marL="0" rtl="0" algn="l">
+              <a:spcBef>
+                <a:spcPts val="0"/>
+              </a:spcBef>
+              <a:spcAft>
+                <a:spcPts val="0"/>
+              </a:spcAft>
+              <a:buNone/>
+            </a:pPr>
+            <a:r>
+              <a:rPr lang="en-US"/>
+              <a:t/>
+            </a:r>
+            <a:endParaRPr/>
+          </a:p>
+          <a:p>
+            <a:pPr indent="0" lvl="0" marL="0" rtl="0" algn="l">
+              <a:spcBef>
+                <a:spcPts val="0"/>
+              </a:spcBef>
+              <a:spcAft>
+                <a:spcPts val="0"/>
+              </a:spcAft>
+              <a:buNone/>
+            </a:pPr>
+            <a:r>
+              <a:t/>
+            </a:r>
+            <a:endParaRPr/>
+          </a:p>
+          <a:p>
+            <a:pPr indent="0" lvl="0" marL="0" rtl="0" algn="l">
+              <a:spcBef>
+                <a:spcPts val="0"/>
+              </a:spcBef>
+              <a:spcAft>
+                <a:spcPts val="0"/>
+              </a:spcAft>
+              <a:buNone/>
+            </a:pPr>
+            <a:r>
+              <a:rPr lang="en-US"/>
+              <a:t/>
+            </a:r>
+            <a:endParaRPr/>
+          </a:p>
+          <a:p>
+            <a:pPr indent="0" lvl="0" marL="0" rtl="0" algn="l">
+              <a:spcBef>
+                <a:spcPts val="0"/>
+              </a:spcBef>
+              <a:spcAft>
+                <a:spcPts val="0"/>
+              </a:spcAft>
+              <a:buNone/>
+            </a:pPr>
+            <a:r>
+              <a:rPr lang="en-US"/>
+              <a:t/>
             </a:r>
             <a:endParaRPr/>
           </a:p>
@@ -2354,116 +2354,116 @@
             </a:pPr>
             <a:r>
               <a:rPr lang="en-US"/>
-              <a:t>S10 · 08/15 · inspeccionar antes de generar.</a:t>
-            </a:r>
-            <a:endParaRPr/>
-          </a:p>
-          <a:p>
-            <a:pPr indent="0" lvl="0" marL="0" rtl="0" algn="l">
-              <a:spcBef>
-                <a:spcPts val="0"/>
-              </a:spcBef>
-              <a:spcAft>
-                <a:spcPts val="0"/>
-              </a:spcAft>
-              <a:buNone/>
-            </a:pPr>
-            <a:r>
-              <a:t/>
-            </a:r>
-            <a:endParaRPr/>
-          </a:p>
-          <a:p>
-            <a:pPr indent="0" lvl="0" marL="0" rtl="0" algn="l">
-              <a:spcBef>
-                <a:spcPts val="0"/>
-              </a:spcBef>
-              <a:spcAft>
-                <a:spcPts val="0"/>
-              </a:spcAft>
-              <a:buNone/>
-            </a:pPr>
-            <a:r>
-              <a:rPr lang="en-US"/>
-              <a:t>Señala Traza de la clase: consulta, puntuación, seleccionado o descartado, decisión y generación.</a:t>
-            </a:r>
-            <a:endParaRPr/>
-          </a:p>
-          <a:p>
-            <a:pPr indent="0" lvl="0" marL="0" rtl="0" algn="l">
-              <a:spcBef>
-                <a:spcPts val="0"/>
-              </a:spcBef>
-              <a:spcAft>
-                <a:spcPts val="0"/>
-              </a:spcAft>
-              <a:buNone/>
-            </a:pPr>
-            <a:r>
-              <a:t/>
-            </a:r>
-            <a:endParaRPr/>
-          </a:p>
-          <a:p>
-            <a:pPr indent="0" lvl="0" marL="0" rtl="0" algn="l">
-              <a:spcBef>
-                <a:spcPts val="0"/>
-              </a:spcBef>
-              <a:spcAft>
-                <a:spcPts val="0"/>
-              </a:spcAft>
-              <a:buNone/>
-            </a:pPr>
-            <a:r>
-              <a:rPr lang="en-US"/>
-              <a:t>Comando ya comprobado: bun run dev. Abre la URL que imprime. El 3 de octubre fue http://localhost:5173/.</a:t>
-            </a:r>
-            <a:endParaRPr/>
-          </a:p>
-          <a:p>
-            <a:pPr indent="0" lvl="0" marL="0" rtl="0" algn="l">
-              <a:spcBef>
-                <a:spcPts val="0"/>
-              </a:spcBef>
-              <a:spcAft>
-                <a:spcPts val="0"/>
-              </a:spcAft>
-              <a:buNone/>
-            </a:pPr>
-            <a:r>
-              <a:t/>
-            </a:r>
-            <a:endParaRPr/>
-          </a:p>
-          <a:p>
-            <a:pPr indent="0" lvl="0" marL="0" rtl="0" algn="l">
-              <a:spcBef>
-                <a:spcPts val="0"/>
-              </a:spcBef>
-              <a:spcAft>
-                <a:spcPts val="0"/>
-              </a:spcAft>
-              <a:buNone/>
-            </a:pPr>
-            <a:r>
-              <a:rPr lang="en-US"/>
-              <a:t>Si la app no arranca, abre material/evidencias/ y di la fecha 3 de octubre de 2026, modo demo, perfil fixture.</a:t>
-            </a:r>
-            <a:endParaRPr/>
-          </a:p>
-          <a:p>
-            <a:pPr indent="0" lvl="0" marL="0" rtl="0" algn="l">
-              <a:spcBef>
-                <a:spcPts val="0"/>
-              </a:spcBef>
-              <a:spcAft>
-                <a:spcPts val="0"/>
-              </a:spcAft>
-              <a:buNone/>
-            </a:pPr>
-            <a:r>
-              <a:rPr lang="en-US"/>
-              <a:t>No llames a esas capturas resultado del servicio remoto.</a:t>
+              <a:t>S10 · 08/15 · bloque 25–40 min. Calibración del umbral con ejemplos de validación separados del conjunto de test. En el demostrador con BGE-M3 el corte quedó en 0,50 (scripts/calibrate-live.ts). En el laboratorio pgvector (LAB_VALIDATION_SET, 6 casos), el negativo más alto dio 0,148 y el positivo más bajo 0,250, fijando el corte en similitud &gt;= 0,25 (distancia &lt;=&gt; &lt;= 0,75). Si no supera el corte, se rechaza sin llamar al generador.</a:t>
+            </a:r>
+            <a:endParaRPr/>
+          </a:p>
+          <a:p>
+            <a:pPr indent="0" lvl="0" marL="0" rtl="0" algn="l">
+              <a:spcBef>
+                <a:spcPts val="0"/>
+              </a:spcBef>
+              <a:spcAft>
+                <a:spcPts val="0"/>
+              </a:spcAft>
+              <a:buNone/>
+            </a:pPr>
+            <a:r>
+              <a:t/>
+            </a:r>
+            <a:endParaRPr/>
+          </a:p>
+          <a:p>
+            <a:pPr indent="0" lvl="0" marL="0" rtl="0" algn="l">
+              <a:spcBef>
+                <a:spcPts val="0"/>
+              </a:spcBef>
+              <a:spcAft>
+                <a:spcPts val="0"/>
+              </a:spcAft>
+              <a:buNone/>
+            </a:pPr>
+            <a:r>
+              <a:rPr lang="en-US"/>
+              <a:t/>
+            </a:r>
+            <a:endParaRPr/>
+          </a:p>
+          <a:p>
+            <a:pPr indent="0" lvl="0" marL="0" rtl="0" algn="l">
+              <a:spcBef>
+                <a:spcPts val="0"/>
+              </a:spcBef>
+              <a:spcAft>
+                <a:spcPts val="0"/>
+              </a:spcAft>
+              <a:buNone/>
+            </a:pPr>
+            <a:r>
+              <a:t/>
+            </a:r>
+            <a:endParaRPr/>
+          </a:p>
+          <a:p>
+            <a:pPr indent="0" lvl="0" marL="0" rtl="0" algn="l">
+              <a:spcBef>
+                <a:spcPts val="0"/>
+              </a:spcBef>
+              <a:spcAft>
+                <a:spcPts val="0"/>
+              </a:spcAft>
+              <a:buNone/>
+            </a:pPr>
+            <a:r>
+              <a:rPr lang="en-US"/>
+              <a:t/>
+            </a:r>
+            <a:endParaRPr/>
+          </a:p>
+          <a:p>
+            <a:pPr indent="0" lvl="0" marL="0" rtl="0" algn="l">
+              <a:spcBef>
+                <a:spcPts val="0"/>
+              </a:spcBef>
+              <a:spcAft>
+                <a:spcPts val="0"/>
+              </a:spcAft>
+              <a:buNone/>
+            </a:pPr>
+            <a:r>
+              <a:t/>
+            </a:r>
+            <a:endParaRPr/>
+          </a:p>
+          <a:p>
+            <a:pPr indent="0" lvl="0" marL="0" rtl="0" algn="l">
+              <a:spcBef>
+                <a:spcPts val="0"/>
+              </a:spcBef>
+              <a:spcAft>
+                <a:spcPts val="0"/>
+              </a:spcAft>
+              <a:buNone/>
+            </a:pPr>
+            <a:r>
+              <a:rPr lang="en-US"/>
+              <a:t/>
+            </a:r>
+            <a:endParaRPr/>
+          </a:p>
+          <a:p>
+            <a:pPr indent="0" lvl="0" marL="0" rtl="0" algn="l">
+              <a:spcBef>
+                <a:spcPts val="0"/>
+              </a:spcBef>
+              <a:spcAft>
+                <a:spcPts val="0"/>
+              </a:spcAft>
+              <a:buNone/>
+            </a:pPr>
+            <a:r>
+              <a:rPr lang="en-US"/>
+              <a:t/>
             </a:r>
             <a:endParaRPr/>
           </a:p>
@@ -3283,131 +3283,131 @@
             </a:pPr>
             <a:r>
               <a:rPr lang="en-US"/>
-              <a:t>S10 · 12/15 · bloque 75–80. Ejercicio. 80–90 preguntas.</a:t>
-            </a:r>
-            <a:endParaRPr/>
-          </a:p>
-          <a:p>
-            <a:pPr indent="0" lvl="0" marL="0" rtl="0" algn="l">
-              <a:spcBef>
-                <a:spcPts val="0"/>
-              </a:spcBef>
-              <a:spcAft>
-                <a:spcPts val="0"/>
-              </a:spcAft>
-              <a:buNone/>
-            </a:pPr>
-            <a:r>
-              <a:t/>
-            </a:r>
-            <a:endParaRPr/>
-          </a:p>
-          <a:p>
-            <a:pPr indent="0" lvl="0" marL="0" rtl="0" algn="l">
-              <a:spcBef>
-                <a:spcPts val="0"/>
-              </a:spcBef>
-              <a:spcAft>
-                <a:spcPts val="0"/>
-              </a:spcAft>
-              <a:buNone/>
-            </a:pPr>
-            <a:r>
-              <a:rPr lang="en-US"/>
-              <a:t>Enunciado: material/ejercicios/S10-enunciado.md.</a:t>
-            </a:r>
-            <a:endParaRPr/>
-          </a:p>
-          <a:p>
-            <a:pPr indent="0" lvl="0" marL="0" rtl="0" algn="l">
-              <a:spcBef>
-                <a:spcPts val="0"/>
-              </a:spcBef>
-              <a:spcAft>
-                <a:spcPts val="0"/>
-              </a:spcAft>
-              <a:buNone/>
-            </a:pPr>
-            <a:r>
-              <a:t/>
-            </a:r>
-            <a:endParaRPr/>
-          </a:p>
-          <a:p>
-            <a:pPr indent="0" lvl="0" marL="0" rtl="0" algn="l">
-              <a:spcBef>
-                <a:spcPts val="0"/>
-              </a:spcBef>
-              <a:spcAft>
-                <a:spcPts val="0"/>
-              </a:spcAft>
-              <a:buNone/>
-            </a:pPr>
-            <a:r>
-              <a:rPr lang="en-US"/>
-              <a:t>Distingue cuatro planos: el encargo original y su evaluación de 20 preguntas, la adaptación de esta demo, el laboratorio fixture y el conjunto reservado del profesor, que no se reparte.</a:t>
-            </a:r>
-            <a:endParaRPr/>
-          </a:p>
-          <a:p>
-            <a:pPr indent="0" lvl="0" marL="0" rtl="0" algn="l">
-              <a:spcBef>
-                <a:spcPts val="0"/>
-              </a:spcBef>
-              <a:spcAft>
-                <a:spcPts val="0"/>
-              </a:spcAft>
-              <a:buNone/>
-            </a:pPr>
-            <a:r>
-              <a:t/>
-            </a:r>
-            <a:endParaRPr/>
-          </a:p>
-          <a:p>
-            <a:pPr indent="0" lvl="0" marL="0" rtl="0" algn="l">
-              <a:spcBef>
-                <a:spcPts val="0"/>
-              </a:spcBef>
-              <a:spcAft>
-                <a:spcPts val="0"/>
-              </a:spcAft>
-              <a:buNone/>
-            </a:pPr>
-            <a:r>
-              <a:rPr lang="en-US"/>
-              <a:t>No pidas a los alumnos que paguen Cloudflare ni que desplieguen.</a:t>
-            </a:r>
-            <a:endParaRPr/>
-          </a:p>
-          <a:p>
-            <a:pPr indent="0" lvl="0" marL="0" rtl="0" algn="l">
-              <a:spcBef>
-                <a:spcPts val="0"/>
-              </a:spcBef>
-              <a:spcAft>
-                <a:spcPts val="0"/>
-              </a:spcAft>
-              <a:buNone/>
-            </a:pPr>
-            <a:r>
-              <a:t/>
-            </a:r>
-            <a:endParaRPr/>
-          </a:p>
-          <a:p>
-            <a:pPr indent="0" lvl="0" marL="0" rtl="0" algn="l">
-              <a:spcBef>
-                <a:spcPts val="0"/>
-              </a:spcBef>
-              <a:spcAft>
-                <a:spcPts val="0"/>
-              </a:spcAft>
-              <a:buNone/>
-            </a:pPr>
-            <a:r>
-              <a:rPr lang="en-US"/>
-              <a:t>Cierra anunciando S11, el 27 de octubre, sobre esta misma aplicación.</a:t>
+              <a:t>S10 · 12/15 · bloque 75–80 min. Enunciado publicado de S10 (material/ejercicios/S10-enunciado.md): 8+ documentos ficticios, PostgreSQL + pgvector, vector(768) e índice HNSW, GEN_MODEL_ID y EMBEDDING_MODEL_ID por variables, reconstrucción desde índice vacío, umbral calibrado y evaluación ejecutada de 20 preguntas (14 respondibles y 6 sin respuesta) presentando resultados X/14 y Y/6. El código de apoyo está en lab/.</a:t>
+            </a:r>
+            <a:endParaRPr/>
+          </a:p>
+          <a:p>
+            <a:pPr indent="0" lvl="0" marL="0" rtl="0" algn="l">
+              <a:spcBef>
+                <a:spcPts val="0"/>
+              </a:spcBef>
+              <a:spcAft>
+                <a:spcPts val="0"/>
+              </a:spcAft>
+              <a:buNone/>
+            </a:pPr>
+            <a:r>
+              <a:t/>
+            </a:r>
+            <a:endParaRPr/>
+          </a:p>
+          <a:p>
+            <a:pPr indent="0" lvl="0" marL="0" rtl="0" algn="l">
+              <a:spcBef>
+                <a:spcPts val="0"/>
+              </a:spcBef>
+              <a:spcAft>
+                <a:spcPts val="0"/>
+              </a:spcAft>
+              <a:buNone/>
+            </a:pPr>
+            <a:r>
+              <a:rPr lang="en-US"/>
+              <a:t/>
+            </a:r>
+            <a:endParaRPr/>
+          </a:p>
+          <a:p>
+            <a:pPr indent="0" lvl="0" marL="0" rtl="0" algn="l">
+              <a:spcBef>
+                <a:spcPts val="0"/>
+              </a:spcBef>
+              <a:spcAft>
+                <a:spcPts val="0"/>
+              </a:spcAft>
+              <a:buNone/>
+            </a:pPr>
+            <a:r>
+              <a:t/>
+            </a:r>
+            <a:endParaRPr/>
+          </a:p>
+          <a:p>
+            <a:pPr indent="0" lvl="0" marL="0" rtl="0" algn="l">
+              <a:spcBef>
+                <a:spcPts val="0"/>
+              </a:spcBef>
+              <a:spcAft>
+                <a:spcPts val="0"/>
+              </a:spcAft>
+              <a:buNone/>
+            </a:pPr>
+            <a:r>
+              <a:rPr lang="en-US"/>
+              <a:t/>
+            </a:r>
+            <a:endParaRPr/>
+          </a:p>
+          <a:p>
+            <a:pPr indent="0" lvl="0" marL="0" rtl="0" algn="l">
+              <a:spcBef>
+                <a:spcPts val="0"/>
+              </a:spcBef>
+              <a:spcAft>
+                <a:spcPts val="0"/>
+              </a:spcAft>
+              <a:buNone/>
+            </a:pPr>
+            <a:r>
+              <a:t/>
+            </a:r>
+            <a:endParaRPr/>
+          </a:p>
+          <a:p>
+            <a:pPr indent="0" lvl="0" marL="0" rtl="0" algn="l">
+              <a:spcBef>
+                <a:spcPts val="0"/>
+              </a:spcBef>
+              <a:spcAft>
+                <a:spcPts val="0"/>
+              </a:spcAft>
+              <a:buNone/>
+            </a:pPr>
+            <a:r>
+              <a:rPr lang="en-US"/>
+              <a:t/>
+            </a:r>
+            <a:endParaRPr/>
+          </a:p>
+          <a:p>
+            <a:pPr indent="0" lvl="0" marL="0" rtl="0" algn="l">
+              <a:spcBef>
+                <a:spcPts val="0"/>
+              </a:spcBef>
+              <a:spcAft>
+                <a:spcPts val="0"/>
+              </a:spcAft>
+              <a:buNone/>
+            </a:pPr>
+            <a:r>
+              <a:t/>
+            </a:r>
+            <a:endParaRPr/>
+          </a:p>
+          <a:p>
+            <a:pPr indent="0" lvl="0" marL="0" rtl="0" algn="l">
+              <a:spcBef>
+                <a:spcPts val="0"/>
+              </a:spcBef>
+              <a:spcAft>
+                <a:spcPts val="0"/>
+              </a:spcAft>
+              <a:buNone/>
+            </a:pPr>
+            <a:r>
+              <a:rPr lang="en-US"/>
+              <a:t/>
             </a:r>
             <a:endParaRPr/>
           </a:p>
@@ -3914,131 +3914,131 @@
             </a:pPr>
             <a:r>
               <a:rPr lang="en-US"/>
-              <a:t>Referencia. No la recorras entera si el tiempo se acaba.</a:t>
-            </a:r>
-            <a:endParaRPr/>
-          </a:p>
-          <a:p>
-            <a:pPr indent="0" lvl="0" marL="0" rtl="0" algn="l">
-              <a:spcBef>
-                <a:spcPts val="0"/>
-              </a:spcBef>
-              <a:spcAft>
-                <a:spcPts val="0"/>
-              </a:spcAft>
-              <a:buNone/>
-            </a:pPr>
-            <a:r>
-              <a:t/>
-            </a:r>
-            <a:endParaRPr/>
-          </a:p>
-          <a:p>
-            <a:pPr indent="0" lvl="0" marL="0" rtl="0" algn="l">
-              <a:spcBef>
-                <a:spcPts val="0"/>
-              </a:spcBef>
-              <a:spcAft>
-                <a:spcPts val="0"/>
-              </a:spcAft>
-              <a:buNone/>
-            </a:pPr>
-            <a:r>
-              <a:rPr lang="en-US"/>
-              <a:t>Demo: fixture lexical. Real: Vectorize y OpenRouter, todavía sin dimensión, sin umbral calibrado y sin MODEL_ID.</a:t>
-            </a:r>
-            <a:endParaRPr/>
-          </a:p>
-          <a:p>
-            <a:pPr indent="0" lvl="0" marL="0" rtl="0" algn="l">
-              <a:spcBef>
-                <a:spcPts val="0"/>
-              </a:spcBef>
-              <a:spcAft>
-                <a:spcPts val="0"/>
-              </a:spcAft>
-              <a:buNone/>
-            </a:pPr>
-            <a:r>
-              <a:t/>
-            </a:r>
-            <a:endParaRPr/>
-          </a:p>
-          <a:p>
-            <a:pPr indent="0" lvl="0" marL="0" rtl="0" algn="l">
-              <a:spcBef>
-                <a:spcPts val="0"/>
-              </a:spcBef>
-              <a:spcAft>
-                <a:spcPts val="0"/>
-              </a:spcAft>
-              <a:buNone/>
-            </a:pPr>
-            <a:r>
-              <a:rPr lang="en-US"/>
-              <a:t>Dos ajustes remotos siguen abiertos: el umbral calibrado y la inyección del secreto de OpenRouter.</a:t>
-            </a:r>
-            <a:endParaRPr/>
-          </a:p>
-          <a:p>
-            <a:pPr indent="0" lvl="0" marL="0" rtl="0" algn="l">
-              <a:spcBef>
-                <a:spcPts val="0"/>
-              </a:spcBef>
-              <a:spcAft>
-                <a:spcPts val="0"/>
-              </a:spcAft>
-              <a:buNone/>
-            </a:pPr>
-            <a:r>
-              <a:t/>
-            </a:r>
-            <a:endParaRPr/>
-          </a:p>
-          <a:p>
-            <a:pPr indent="0" lvl="0" marL="0" rtl="0" algn="l">
-              <a:spcBef>
-                <a:spcPts val="0"/>
-              </a:spcBef>
-              <a:spcAft>
-                <a:spcPts val="0"/>
-              </a:spcAft>
-              <a:buNone/>
-            </a:pPr>
-            <a:r>
-              <a:rPr lang="en-US"/>
-              <a:t>Entregar un tope de gasto no basta para declarar probado el camino real.</a:t>
-            </a:r>
-            <a:endParaRPr/>
-          </a:p>
-          <a:p>
-            <a:pPr indent="0" lvl="0" marL="0" rtl="0" algn="l">
-              <a:spcBef>
-                <a:spcPts val="0"/>
-              </a:spcBef>
-              <a:spcAft>
-                <a:spcPts val="0"/>
-              </a:spcAft>
-              <a:buNone/>
-            </a:pPr>
-            <a:r>
-              <a:t/>
-            </a:r>
-            <a:endParaRPr/>
-          </a:p>
-          <a:p>
-            <a:pPr indent="0" lvl="0" marL="0" rtl="0" algn="l">
-              <a:spcBef>
-                <a:spcPts val="0"/>
-              </a:spcBef>
-              <a:spcAft>
-                <a:spcPts val="0"/>
-              </a:spcAft>
-              <a:buNone/>
-            </a:pPr>
-            <a:r>
-              <a:rPr lang="en-US"/>
-              <a:t>Fase 7 verificada en local el 3 de octubre de 2026. Sin alta ni llamada de pago.</a:t>
+              <a:t>S10 · 13/15 · referencia de los tres perfiles. 1) Curso en modo semántico: Vectorize BGE-M3 1024 d (p76509a5f9743), claude-haiku-5-5, corte 0,50 (y variante complete sobre D1). 2) Laboratorio reproducible del ejercicio (lab/): PostgreSQL + pgvector vector(768) + HNSW, 10 documentos de AetherCloud, corte 0,25. 3) Respaldo offline demo: fixture-token-hash-v1 128 d, corte 0,33.</a:t>
+            </a:r>
+            <a:endParaRPr/>
+          </a:p>
+          <a:p>
+            <a:pPr indent="0" lvl="0" marL="0" rtl="0" algn="l">
+              <a:spcBef>
+                <a:spcPts val="0"/>
+              </a:spcBef>
+              <a:spcAft>
+                <a:spcPts val="0"/>
+              </a:spcAft>
+              <a:buNone/>
+            </a:pPr>
+            <a:r>
+              <a:t/>
+            </a:r>
+            <a:endParaRPr/>
+          </a:p>
+          <a:p>
+            <a:pPr indent="0" lvl="0" marL="0" rtl="0" algn="l">
+              <a:spcBef>
+                <a:spcPts val="0"/>
+              </a:spcBef>
+              <a:spcAft>
+                <a:spcPts val="0"/>
+              </a:spcAft>
+              <a:buNone/>
+            </a:pPr>
+            <a:r>
+              <a:rPr lang="en-US"/>
+              <a:t/>
+            </a:r>
+            <a:endParaRPr/>
+          </a:p>
+          <a:p>
+            <a:pPr indent="0" lvl="0" marL="0" rtl="0" algn="l">
+              <a:spcBef>
+                <a:spcPts val="0"/>
+              </a:spcBef>
+              <a:spcAft>
+                <a:spcPts val="0"/>
+              </a:spcAft>
+              <a:buNone/>
+            </a:pPr>
+            <a:r>
+              <a:t/>
+            </a:r>
+            <a:endParaRPr/>
+          </a:p>
+          <a:p>
+            <a:pPr indent="0" lvl="0" marL="0" rtl="0" algn="l">
+              <a:spcBef>
+                <a:spcPts val="0"/>
+              </a:spcBef>
+              <a:spcAft>
+                <a:spcPts val="0"/>
+              </a:spcAft>
+              <a:buNone/>
+            </a:pPr>
+            <a:r>
+              <a:rPr lang="en-US"/>
+              <a:t/>
+            </a:r>
+            <a:endParaRPr/>
+          </a:p>
+          <a:p>
+            <a:pPr indent="0" lvl="0" marL="0" rtl="0" algn="l">
+              <a:spcBef>
+                <a:spcPts val="0"/>
+              </a:spcBef>
+              <a:spcAft>
+                <a:spcPts val="0"/>
+              </a:spcAft>
+              <a:buNone/>
+            </a:pPr>
+            <a:r>
+              <a:t/>
+            </a:r>
+            <a:endParaRPr/>
+          </a:p>
+          <a:p>
+            <a:pPr indent="0" lvl="0" marL="0" rtl="0" algn="l">
+              <a:spcBef>
+                <a:spcPts val="0"/>
+              </a:spcBef>
+              <a:spcAft>
+                <a:spcPts val="0"/>
+              </a:spcAft>
+              <a:buNone/>
+            </a:pPr>
+            <a:r>
+              <a:rPr lang="en-US"/>
+              <a:t/>
+            </a:r>
+            <a:endParaRPr/>
+          </a:p>
+          <a:p>
+            <a:pPr indent="0" lvl="0" marL="0" rtl="0" algn="l">
+              <a:spcBef>
+                <a:spcPts val="0"/>
+              </a:spcBef>
+              <a:spcAft>
+                <a:spcPts val="0"/>
+              </a:spcAft>
+              <a:buNone/>
+            </a:pPr>
+            <a:r>
+              <a:t/>
+            </a:r>
+            <a:endParaRPr/>
+          </a:p>
+          <a:p>
+            <a:pPr indent="0" lvl="0" marL="0" rtl="0" algn="l">
+              <a:spcBef>
+                <a:spcPts val="0"/>
+              </a:spcBef>
+              <a:spcAft>
+                <a:spcPts val="0"/>
+              </a:spcAft>
+              <a:buNone/>
+            </a:pPr>
+            <a:r>
+              <a:rPr lang="en-US"/>
+              <a:t/>
             </a:r>
             <a:endParaRPr/>
           </a:p>
@@ -4574,131 +4574,131 @@
             </a:pPr>
             <a:r>
               <a:rPr lang="en-US"/>
-              <a:t>Referencia de recuperación.</a:t>
-            </a:r>
-            <a:endParaRPr/>
-          </a:p>
-          <a:p>
-            <a:pPr indent="0" lvl="0" marL="0" rtl="0" algn="l">
-              <a:spcBef>
-                <a:spcPts val="0"/>
-              </a:spcBef>
-              <a:spcAft>
-                <a:spcPts val="0"/>
-              </a:spcAft>
-              <a:buNone/>
-            </a:pPr>
-            <a:r>
-              <a:t/>
-            </a:r>
-            <a:endParaRPr/>
-          </a:p>
-          <a:p>
-            <a:pPr indent="0" lvl="0" marL="0" rtl="0" algn="l">
-              <a:spcBef>
-                <a:spcPts val="0"/>
-              </a:spcBef>
-              <a:spcAft>
-                <a:spcPts val="0"/>
-              </a:spcAft>
-              <a:buNone/>
-            </a:pPr>
-            <a:r>
-              <a:rPr lang="en-US"/>
-              <a:t>1. bun run preflight. Lee fuente efectiva y APP_MODE efectivo. Si no es demo, corrige esa fuente: .dev.vars pisa wrangler.jsonc y reiniciar no lo quita. 2. bun run dev y abre la URL impresa. 3. Captura en material/evidencias. 4. Vuelve a la diapositiva. No uses activate --execute.</a:t>
-            </a:r>
-            <a:endParaRPr/>
-          </a:p>
-          <a:p>
-            <a:pPr indent="0" lvl="0" marL="0" rtl="0" algn="l">
-              <a:spcBef>
-                <a:spcPts val="0"/>
-              </a:spcBef>
-              <a:spcAft>
-                <a:spcPts val="0"/>
-              </a:spcAft>
-              <a:buNone/>
-            </a:pPr>
-            <a:r>
-              <a:t/>
-            </a:r>
-            <a:endParaRPr/>
-          </a:p>
-          <a:p>
-            <a:pPr indent="0" lvl="0" marL="0" rtl="0" algn="l">
-              <a:spcBef>
-                <a:spcPts val="0"/>
-              </a:spcBef>
-              <a:spcAft>
-                <a:spcPts val="0"/>
-              </a:spcAft>
-              <a:buNone/>
-            </a:pPr>
-            <a:r>
-              <a:rPr lang="en-US"/>
-              <a:t>bun run activate y bun run activate -- plan salen a 0 y no llaman a la red.</a:t>
-            </a:r>
-            <a:endParaRPr/>
-          </a:p>
-          <a:p>
-            <a:pPr indent="0" lvl="0" marL="0" rtl="0" algn="l">
-              <a:spcBef>
-                <a:spcPts val="0"/>
-              </a:spcBef>
-              <a:spcAft>
-                <a:spcPts val="0"/>
-              </a:spcAft>
-              <a:buNone/>
-            </a:pPr>
-            <a:r>
-              <a:t/>
-            </a:r>
-            <a:endParaRPr/>
-          </a:p>
-          <a:p>
-            <a:pPr indent="0" lvl="0" marL="0" rtl="0" algn="l">
-              <a:spcBef>
-                <a:spcPts val="0"/>
-              </a:spcBef>
-              <a:spcAft>
-                <a:spcPts val="0"/>
-              </a:spcAft>
-              <a:buNone/>
-            </a:pPr>
-            <a:r>
-              <a:rPr lang="en-US"/>
-              <a:t>status --read sí hablaría con la cuenta. No lo uses como plan B de la clase.</a:t>
-            </a:r>
-            <a:endParaRPr/>
-          </a:p>
-          <a:p>
-            <a:pPr indent="0" lvl="0" marL="0" rtl="0" algn="l">
-              <a:spcBef>
-                <a:spcPts val="0"/>
-              </a:spcBef>
-              <a:spcAft>
-                <a:spcPts val="0"/>
-              </a:spcAft>
-              <a:buNone/>
-            </a:pPr>
-            <a:r>
-              <a:t/>
-            </a:r>
-            <a:endParaRPr/>
-          </a:p>
-          <a:p>
-            <a:pPr indent="0" lvl="0" marL="0" rtl="0" algn="l">
-              <a:spcBef>
-                <a:spcPts val="0"/>
-              </a:spcBef>
-              <a:spcAft>
-                <a:spcPts val="0"/>
-              </a:spcAft>
-              <a:buNone/>
-            </a:pPr>
-            <a:r>
-              <a:rPr lang="en-US"/>
-              <a:t>activate --execute sin autorización sale 2 y no abre el puente. No lo fuerces.</a:t>
+              <a:t>S10 · 14/15 · referencia de respaldo local. Si necesitas cambiar a la demo local sin red, comprueba bun run preflight (APP_MODE efectivo: demo) y ejecuta bun run dev o bun run lab:demo. No lances activate --execute en directo.</a:t>
+            </a:r>
+            <a:endParaRPr/>
+          </a:p>
+          <a:p>
+            <a:pPr indent="0" lvl="0" marL="0" rtl="0" algn="l">
+              <a:spcBef>
+                <a:spcPts val="0"/>
+              </a:spcBef>
+              <a:spcAft>
+                <a:spcPts val="0"/>
+              </a:spcAft>
+              <a:buNone/>
+            </a:pPr>
+            <a:r>
+              <a:t/>
+            </a:r>
+            <a:endParaRPr/>
+          </a:p>
+          <a:p>
+            <a:pPr indent="0" lvl="0" marL="0" rtl="0" algn="l">
+              <a:spcBef>
+                <a:spcPts val="0"/>
+              </a:spcBef>
+              <a:spcAft>
+                <a:spcPts val="0"/>
+              </a:spcAft>
+              <a:buNone/>
+            </a:pPr>
+            <a:r>
+              <a:rPr lang="en-US"/>
+              <a:t/>
+            </a:r>
+            <a:endParaRPr/>
+          </a:p>
+          <a:p>
+            <a:pPr indent="0" lvl="0" marL="0" rtl="0" algn="l">
+              <a:spcBef>
+                <a:spcPts val="0"/>
+              </a:spcBef>
+              <a:spcAft>
+                <a:spcPts val="0"/>
+              </a:spcAft>
+              <a:buNone/>
+            </a:pPr>
+            <a:r>
+              <a:t/>
+            </a:r>
+            <a:endParaRPr/>
+          </a:p>
+          <a:p>
+            <a:pPr indent="0" lvl="0" marL="0" rtl="0" algn="l">
+              <a:spcBef>
+                <a:spcPts val="0"/>
+              </a:spcBef>
+              <a:spcAft>
+                <a:spcPts val="0"/>
+              </a:spcAft>
+              <a:buNone/>
+            </a:pPr>
+            <a:r>
+              <a:rPr lang="en-US"/>
+              <a:t/>
+            </a:r>
+            <a:endParaRPr/>
+          </a:p>
+          <a:p>
+            <a:pPr indent="0" lvl="0" marL="0" rtl="0" algn="l">
+              <a:spcBef>
+                <a:spcPts val="0"/>
+              </a:spcBef>
+              <a:spcAft>
+                <a:spcPts val="0"/>
+              </a:spcAft>
+              <a:buNone/>
+            </a:pPr>
+            <a:r>
+              <a:t/>
+            </a:r>
+            <a:endParaRPr/>
+          </a:p>
+          <a:p>
+            <a:pPr indent="0" lvl="0" marL="0" rtl="0" algn="l">
+              <a:spcBef>
+                <a:spcPts val="0"/>
+              </a:spcBef>
+              <a:spcAft>
+                <a:spcPts val="0"/>
+              </a:spcAft>
+              <a:buNone/>
+            </a:pPr>
+            <a:r>
+              <a:rPr lang="en-US"/>
+              <a:t/>
+            </a:r>
+            <a:endParaRPr/>
+          </a:p>
+          <a:p>
+            <a:pPr indent="0" lvl="0" marL="0" rtl="0" algn="l">
+              <a:spcBef>
+                <a:spcPts val="0"/>
+              </a:spcBef>
+              <a:spcAft>
+                <a:spcPts val="0"/>
+              </a:spcAft>
+              <a:buNone/>
+            </a:pPr>
+            <a:r>
+              <a:t/>
+            </a:r>
+            <a:endParaRPr/>
+          </a:p>
+          <a:p>
+            <a:pPr indent="0" lvl="0" marL="0" rtl="0" algn="l">
+              <a:spcBef>
+                <a:spcPts val="0"/>
+              </a:spcBef>
+              <a:spcAft>
+                <a:spcPts val="0"/>
+              </a:spcAft>
+              <a:buNone/>
+            </a:pPr>
+            <a:r>
+              <a:rPr lang="en-US"/>
+              <a:t/>
             </a:r>
             <a:endParaRPr/>
           </a:p>
@@ -5220,100 +5220,100 @@
             </a:pPr>
             <a:r>
               <a:rPr lang="en-US"/>
-              <a:t>S10 · 15/15 · cierre.</a:t>
-            </a:r>
-            <a:endParaRPr/>
-          </a:p>
-          <a:p>
-            <a:pPr indent="0" lvl="0" marL="0" rtl="0" algn="l">
-              <a:spcBef>
-                <a:spcPts val="0"/>
-              </a:spcBef>
-              <a:spcAft>
-                <a:spcPts val="0"/>
-              </a:spcAft>
-              <a:buNone/>
-            </a:pPr>
-            <a:r>
-              <a:t/>
-            </a:r>
-            <a:endParaRPr/>
-          </a:p>
-          <a:p>
-            <a:pPr indent="0" lvl="0" marL="0" rtl="0" algn="l">
-              <a:spcBef>
-                <a:spcPts val="0"/>
-              </a:spcBef>
-              <a:spcAft>
-                <a:spcPts val="0"/>
-              </a:spcAft>
-              <a:buNone/>
-            </a:pPr>
-            <a:r>
-              <a:rPr lang="en-US"/>
-              <a:t>Deja el QR visible. Evalúa S9, no la clase de hoy.</a:t>
-            </a:r>
-            <a:endParaRPr/>
-          </a:p>
-          <a:p>
-            <a:pPr indent="0" lvl="0" marL="0" rtl="0" algn="l">
-              <a:spcBef>
-                <a:spcPts val="0"/>
-              </a:spcBef>
-              <a:spcAft>
-                <a:spcPts val="0"/>
-              </a:spcAft>
-              <a:buNone/>
-            </a:pPr>
-            <a:r>
-              <a:t/>
-            </a:r>
-            <a:endParaRPr/>
-          </a:p>
-          <a:p>
-            <a:pPr indent="0" lvl="0" marL="0" rtl="0" algn="l">
-              <a:spcBef>
-                <a:spcPts val="0"/>
-              </a:spcBef>
-              <a:spcAft>
-                <a:spcPts val="0"/>
-              </a:spcAft>
-              <a:buNone/>
-            </a:pPr>
-            <a:r>
-              <a:rPr lang="en-US"/>
-              <a:t>No envíes ninguna evaluación.</a:t>
-            </a:r>
-            <a:endParaRPr/>
-          </a:p>
-          <a:p>
-            <a:pPr indent="0" lvl="0" marL="0" rtl="0" algn="l">
-              <a:spcBef>
-                <a:spcPts val="0"/>
-              </a:spcBef>
-              <a:spcAft>
-                <a:spcPts val="0"/>
-              </a:spcAft>
-              <a:buNone/>
-            </a:pPr>
-            <a:r>
-              <a:t/>
-            </a:r>
-            <a:endParaRPr/>
-          </a:p>
-          <a:p>
-            <a:pPr indent="0" lvl="0" marL="0" rtl="0" algn="l">
-              <a:spcBef>
-                <a:spcPts val="0"/>
-              </a:spcBef>
-              <a:spcAft>
-                <a:spcPts val="0"/>
-              </a:spcAft>
-              <a:buNone/>
-            </a:pPr>
-            <a:r>
-              <a:rPr lang="en-US"/>
-              <a:t>Anuncia S11 el 27 de octubre sobre la misma aplicación.</a:t>
+              <a:t>S10 · 15/15 · cierre y preguntas (80–90 min). Deja el QR visible (evalúa S9). El martes 27 de octubre en S11 evolucionamos este mismo sistema y el laboratorio pgvector hacia Corrective RAG (CRAG).</a:t>
+            </a:r>
+            <a:endParaRPr/>
+          </a:p>
+          <a:p>
+            <a:pPr indent="0" lvl="0" marL="0" rtl="0" algn="l">
+              <a:spcBef>
+                <a:spcPts val="0"/>
+              </a:spcBef>
+              <a:spcAft>
+                <a:spcPts val="0"/>
+              </a:spcAft>
+              <a:buNone/>
+            </a:pPr>
+            <a:r>
+              <a:t/>
+            </a:r>
+            <a:endParaRPr/>
+          </a:p>
+          <a:p>
+            <a:pPr indent="0" lvl="0" marL="0" rtl="0" algn="l">
+              <a:spcBef>
+                <a:spcPts val="0"/>
+              </a:spcBef>
+              <a:spcAft>
+                <a:spcPts val="0"/>
+              </a:spcAft>
+              <a:buNone/>
+            </a:pPr>
+            <a:r>
+              <a:rPr lang="en-US"/>
+              <a:t/>
+            </a:r>
+            <a:endParaRPr/>
+          </a:p>
+          <a:p>
+            <a:pPr indent="0" lvl="0" marL="0" rtl="0" algn="l">
+              <a:spcBef>
+                <a:spcPts val="0"/>
+              </a:spcBef>
+              <a:spcAft>
+                <a:spcPts val="0"/>
+              </a:spcAft>
+              <a:buNone/>
+            </a:pPr>
+            <a:r>
+              <a:t/>
+            </a:r>
+            <a:endParaRPr/>
+          </a:p>
+          <a:p>
+            <a:pPr indent="0" lvl="0" marL="0" rtl="0" algn="l">
+              <a:spcBef>
+                <a:spcPts val="0"/>
+              </a:spcBef>
+              <a:spcAft>
+                <a:spcPts val="0"/>
+              </a:spcAft>
+              <a:buNone/>
+            </a:pPr>
+            <a:r>
+              <a:rPr lang="en-US"/>
+              <a:t/>
+            </a:r>
+            <a:endParaRPr/>
+          </a:p>
+          <a:p>
+            <a:pPr indent="0" lvl="0" marL="0" rtl="0" algn="l">
+              <a:spcBef>
+                <a:spcPts val="0"/>
+              </a:spcBef>
+              <a:spcAft>
+                <a:spcPts val="0"/>
+              </a:spcAft>
+              <a:buNone/>
+            </a:pPr>
+            <a:r>
+              <a:t/>
+            </a:r>
+            <a:endParaRPr/>
+          </a:p>
+          <a:p>
+            <a:pPr indent="0" lvl="0" marL="0" rtl="0" algn="l">
+              <a:spcBef>
+                <a:spcPts val="0"/>
+              </a:spcBef>
+              <a:spcAft>
+                <a:spcPts val="0"/>
+              </a:spcAft>
+              <a:buNone/>
+            </a:pPr>
+            <a:r>
+              <a:rPr lang="en-US"/>
+              <a:t/>
             </a:r>
             <a:endParaRPr/>
           </a:p>
@@ -5880,131 +5880,131 @@
             </a:pPr>
             <a:r>
               <a:rPr lang="en-US"/>
-              <a:t>S10 · 02/15 · dentro de 0–10 min. QR y objetivos.</a:t>
-            </a:r>
-            <a:endParaRPr/>
-          </a:p>
-          <a:p>
-            <a:pPr indent="0" lvl="0" marL="0" rtl="0" algn="l">
-              <a:spcBef>
-                <a:spcPts val="0"/>
-              </a:spcBef>
-              <a:spcAft>
-                <a:spcPts val="0"/>
-              </a:spcAft>
-              <a:buNone/>
-            </a:pPr>
-            <a:r>
-              <a:t/>
-            </a:r>
-            <a:endParaRPr/>
-          </a:p>
-          <a:p>
-            <a:pPr indent="0" lvl="0" marL="0" rtl="0" algn="l">
-              <a:spcBef>
-                <a:spcPts val="0"/>
-              </a:spcBef>
-              <a:spcAft>
-                <a:spcPts val="0"/>
-              </a:spcAft>
-              <a:buNone/>
-            </a:pPr>
-            <a:r>
-              <a:rPr lang="en-US"/>
-              <a:t>Di: este QR evalúa S9, la clase M/J del 20 de octubre. No envía la práctica de hoy.</a:t>
-            </a:r>
-            <a:endParaRPr/>
-          </a:p>
-          <a:p>
-            <a:pPr indent="0" lvl="0" marL="0" rtl="0" algn="l">
-              <a:spcBef>
-                <a:spcPts val="0"/>
-              </a:spcBef>
-              <a:spcAft>
-                <a:spcPts val="0"/>
-              </a:spcAft>
-              <a:buNone/>
-            </a:pPr>
-            <a:r>
-              <a:t/>
-            </a:r>
-            <a:endParaRPr/>
-          </a:p>
-          <a:p>
-            <a:pPr indent="0" lvl="0" marL="0" rtl="0" algn="l">
-              <a:spcBef>
-                <a:spcPts val="0"/>
-              </a:spcBef>
-              <a:spcAft>
-                <a:spcPts val="0"/>
-              </a:spcAft>
-              <a:buNone/>
-            </a:pPr>
-            <a:r>
-              <a:rPr lang="en-US"/>
-              <a:t>Destino del QR: formulario de feedback de AI Engineer. No inventes otra URL.</a:t>
-            </a:r>
-            <a:endParaRPr/>
-          </a:p>
-          <a:p>
-            <a:pPr indent="0" lvl="0" marL="0" rtl="0" algn="l">
-              <a:spcBef>
-                <a:spcPts val="0"/>
-              </a:spcBef>
-              <a:spcAft>
-                <a:spcPts val="0"/>
-              </a:spcAft>
-              <a:buNone/>
-            </a:pPr>
-            <a:r>
-              <a:t/>
-            </a:r>
-            <a:endParaRPr/>
-          </a:p>
-          <a:p>
-            <a:pPr indent="0" lvl="0" marL="0" rtl="0" algn="l">
-              <a:spcBef>
-                <a:spcPts val="0"/>
-              </a:spcBef>
-              <a:spcAft>
-                <a:spcPts val="0"/>
-              </a:spcAft>
-              <a:buNone/>
-            </a:pPr>
-            <a:r>
-              <a:rPr lang="en-US"/>
-              <a:t>Hoy: sin RAG, corpus, una búsqueda, citas, rechazo y cohorte.</a:t>
-            </a:r>
-            <a:endParaRPr/>
-          </a:p>
-          <a:p>
-            <a:pPr indent="0" lvl="0" marL="0" rtl="0" algn="l">
-              <a:spcBef>
-                <a:spcPts val="0"/>
-              </a:spcBef>
-              <a:spcAft>
-                <a:spcPts val="0"/>
-              </a:spcAft>
-              <a:buNone/>
-            </a:pPr>
-            <a:r>
-              <a:t/>
-            </a:r>
-            <a:endParaRPr/>
-          </a:p>
-          <a:p>
-            <a:pPr indent="0" lvl="0" marL="0" rtl="0" algn="l">
-              <a:spcBef>
-                <a:spcPts val="0"/>
-              </a:spcBef>
-              <a:spcAft>
-                <a:spcPts val="0"/>
-              </a:spcAft>
-              <a:buNone/>
-            </a:pPr>
-            <a:r>
-              <a:rPr lang="en-US"/>
-              <a:t>Si el QR no se lee, usa la copia de material/assets/qr-ai-engineer.jpg.</a:t>
+              <a:t>S10 · 02/15 · bloque 0–10 min. QR de AI Engineer: evalúa la sesión anterior (S9, PostgreSQL y pgvector del 20 de octubre). Hoy conectamos directamente con S9 llevando los embeddings a la columna vector(768) con índice HNSW y añadiendo selección de contexto, umbral calibrado, citas y evaluación 14+6.</a:t>
+            </a:r>
+            <a:endParaRPr/>
+          </a:p>
+          <a:p>
+            <a:pPr indent="0" lvl="0" marL="0" rtl="0" algn="l">
+              <a:spcBef>
+                <a:spcPts val="0"/>
+              </a:spcBef>
+              <a:spcAft>
+                <a:spcPts val="0"/>
+              </a:spcAft>
+              <a:buNone/>
+            </a:pPr>
+            <a:r>
+              <a:t/>
+            </a:r>
+            <a:endParaRPr/>
+          </a:p>
+          <a:p>
+            <a:pPr indent="0" lvl="0" marL="0" rtl="0" algn="l">
+              <a:spcBef>
+                <a:spcPts val="0"/>
+              </a:spcBef>
+              <a:spcAft>
+                <a:spcPts val="0"/>
+              </a:spcAft>
+              <a:buNone/>
+            </a:pPr>
+            <a:r>
+              <a:rPr lang="en-US"/>
+              <a:t/>
+            </a:r>
+            <a:endParaRPr/>
+          </a:p>
+          <a:p>
+            <a:pPr indent="0" lvl="0" marL="0" rtl="0" algn="l">
+              <a:spcBef>
+                <a:spcPts val="0"/>
+              </a:spcBef>
+              <a:spcAft>
+                <a:spcPts val="0"/>
+              </a:spcAft>
+              <a:buNone/>
+            </a:pPr>
+            <a:r>
+              <a:t/>
+            </a:r>
+            <a:endParaRPr/>
+          </a:p>
+          <a:p>
+            <a:pPr indent="0" lvl="0" marL="0" rtl="0" algn="l">
+              <a:spcBef>
+                <a:spcPts val="0"/>
+              </a:spcBef>
+              <a:spcAft>
+                <a:spcPts val="0"/>
+              </a:spcAft>
+              <a:buNone/>
+            </a:pPr>
+            <a:r>
+              <a:rPr lang="en-US"/>
+              <a:t/>
+            </a:r>
+            <a:endParaRPr/>
+          </a:p>
+          <a:p>
+            <a:pPr indent="0" lvl="0" marL="0" rtl="0" algn="l">
+              <a:spcBef>
+                <a:spcPts val="0"/>
+              </a:spcBef>
+              <a:spcAft>
+                <a:spcPts val="0"/>
+              </a:spcAft>
+              <a:buNone/>
+            </a:pPr>
+            <a:r>
+              <a:t/>
+            </a:r>
+            <a:endParaRPr/>
+          </a:p>
+          <a:p>
+            <a:pPr indent="0" lvl="0" marL="0" rtl="0" algn="l">
+              <a:spcBef>
+                <a:spcPts val="0"/>
+              </a:spcBef>
+              <a:spcAft>
+                <a:spcPts val="0"/>
+              </a:spcAft>
+              <a:buNone/>
+            </a:pPr>
+            <a:r>
+              <a:rPr lang="en-US"/>
+              <a:t/>
+            </a:r>
+            <a:endParaRPr/>
+          </a:p>
+          <a:p>
+            <a:pPr indent="0" lvl="0" marL="0" rtl="0" algn="l">
+              <a:spcBef>
+                <a:spcPts val="0"/>
+              </a:spcBef>
+              <a:spcAft>
+                <a:spcPts val="0"/>
+              </a:spcAft>
+              <a:buNone/>
+            </a:pPr>
+            <a:r>
+              <a:t/>
+            </a:r>
+            <a:endParaRPr/>
+          </a:p>
+          <a:p>
+            <a:pPr indent="0" lvl="0" marL="0" rtl="0" algn="l">
+              <a:spcBef>
+                <a:spcPts val="0"/>
+              </a:spcBef>
+              <a:spcAft>
+                <a:spcPts val="0"/>
+              </a:spcAft>
+              <a:buNone/>
+            </a:pPr>
+            <a:r>
+              <a:rPr lang="en-US"/>
+              <a:t/>
             </a:r>
             <a:endParaRPr/>
           </a:p>
@@ -6540,162 +6540,162 @@
             </a:pPr>
             <a:r>
               <a:rPr lang="en-US"/>
-              <a:t>S10 · 03/15 · sigue el bloque 0–10.</a:t>
-            </a:r>
-            <a:endParaRPr/>
-          </a:p>
-          <a:p>
-            <a:pPr indent="0" lvl="0" marL="0" rtl="0" algn="l">
-              <a:spcBef>
-                <a:spcPts val="0"/>
-              </a:spcBef>
-              <a:spcAft>
-                <a:spcPts val="0"/>
-              </a:spcAft>
-              <a:buNone/>
-            </a:pPr>
-            <a:r>
-              <a:t/>
-            </a:r>
-            <a:endParaRPr/>
-          </a:p>
-          <a:p>
-            <a:pPr indent="0" lvl="0" marL="0" rtl="0" algn="l">
-              <a:spcBef>
-                <a:spcPts val="0"/>
-              </a:spcBef>
-              <a:spcAft>
-                <a:spcPts val="0"/>
-              </a:spcAft>
-              <a:buNone/>
-            </a:pPr>
-            <a:r>
-              <a:rPr lang="en-US"/>
-              <a:t>Abre la URL que imprime bun run dev. El 3 de octubre fue http://localhost:5173/. Etapa Sin RAG. Audiencia General.</a:t>
-            </a:r>
-            <a:endParaRPr/>
-          </a:p>
-          <a:p>
-            <a:pPr indent="0" lvl="0" marL="0" rtl="0" algn="l">
-              <a:spcBef>
-                <a:spcPts val="0"/>
-              </a:spcBef>
-              <a:spcAft>
-                <a:spcPts val="0"/>
-              </a:spcAft>
-              <a:buNone/>
-            </a:pPr>
-            <a:r>
-              <a:t/>
-            </a:r>
-            <a:endParaRPr/>
-          </a:p>
-          <a:p>
-            <a:pPr indent="0" lvl="0" marL="0" rtl="0" algn="l">
-              <a:spcBef>
-                <a:spcPts val="0"/>
-              </a:spcBef>
-              <a:spcAft>
-                <a:spcPts val="0"/>
-              </a:spcAft>
-              <a:buNone/>
-            </a:pPr>
-            <a:r>
-              <a:rPr lang="en-US"/>
-              <a:t>Escribe: ¿Cómo modela LangGraph un agente con estado y nodos?</a:t>
-            </a:r>
-            <a:endParaRPr/>
-          </a:p>
-          <a:p>
-            <a:pPr indent="0" lvl="0" marL="0" rtl="0" algn="l">
-              <a:spcBef>
-                <a:spcPts val="0"/>
-              </a:spcBef>
-              <a:spcAft>
-                <a:spcPts val="0"/>
-              </a:spcAft>
-              <a:buNone/>
-            </a:pPr>
-            <a:r>
-              <a:t/>
-            </a:r>
-            <a:endParaRPr/>
-          </a:p>
-          <a:p>
-            <a:pPr indent="0" lvl="0" marL="0" rtl="0" algn="l">
-              <a:spcBef>
-                <a:spcPts val="0"/>
-              </a:spcBef>
-              <a:spcAft>
-                <a:spcPts val="0"/>
-              </a:spcAft>
-              <a:buNone/>
-            </a:pPr>
-            <a:r>
-              <a:rPr lang="en-US"/>
-              <a:t>Debe salir un stream offline-demo, sin fuentes. Uso y coste: no medido.</a:t>
-            </a:r>
-            <a:endParaRPr/>
-          </a:p>
-          <a:p>
-            <a:pPr indent="0" lvl="0" marL="0" rtl="0" algn="l">
-              <a:spcBef>
-                <a:spcPts val="0"/>
-              </a:spcBef>
-              <a:spcAft>
-                <a:spcPts val="0"/>
-              </a:spcAft>
-              <a:buNone/>
-            </a:pPr>
-            <a:r>
-              <a:t/>
-            </a:r>
-            <a:endParaRPr/>
-          </a:p>
-          <a:p>
-            <a:pPr indent="0" lvl="0" marL="0" rtl="0" algn="l">
-              <a:spcBef>
-                <a:spcPts val="0"/>
-              </a:spcBef>
-              <a:spcAft>
-                <a:spcPts val="0"/>
-              </a:spcAft>
-              <a:buNone/>
-            </a:pPr>
-            <a:r>
-              <a:rPr lang="en-US"/>
-              <a:t>Di: una respuesta genérica o una abstención serían aceptables. No pidas al modelo que invente para demostrar el fallo.</a:t>
-            </a:r>
-            <a:endParaRPr/>
-          </a:p>
-          <a:p>
-            <a:pPr indent="0" lvl="0" marL="0" rtl="0" algn="l">
-              <a:spcBef>
-                <a:spcPts val="0"/>
-              </a:spcBef>
-              <a:spcAft>
-                <a:spcPts val="0"/>
-              </a:spcAft>
-              <a:buNone/>
-            </a:pPr>
-            <a:r>
-              <a:t/>
-            </a:r>
-            <a:endParaRPr/>
-          </a:p>
-          <a:p>
-            <a:pPr indent="0" lvl="0" marL="0" rtl="0" algn="l">
-              <a:spcBef>
-                <a:spcPts val="0"/>
-              </a:spcBef>
-              <a:spcAft>
-                <a:spcPts val="0"/>
-              </a:spcAft>
-              <a:buNone/>
-            </a:pPr>
-            <a:r>
-              <a:rPr lang="en-US"/>
-              <a:t>En demo ni siquiera hay modelo. No lo presentes como GPT ni como OpenRouter.</a:t>
+              <a:t>S10 · 03/15 · bloque 0–10 min. Etapa Sin RAG. Pregunta por la fecha exacta de S10 en la cohorte M/J o por un detalle específico del programa. Con modelo real (claude-haiku-5-5) se abstiene o responde de forma genérica sin citas; en respaldo demo devuelve el stream etiquetado offline-demo. Señala que uso y coste desconocidos viajan como null, nunca como cero.</a:t>
+            </a:r>
+            <a:endParaRPr/>
+          </a:p>
+          <a:p>
+            <a:pPr indent="0" lvl="0" marL="0" rtl="0" algn="l">
+              <a:spcBef>
+                <a:spcPts val="0"/>
+              </a:spcBef>
+              <a:spcAft>
+                <a:spcPts val="0"/>
+              </a:spcAft>
+              <a:buNone/>
+            </a:pPr>
+            <a:r>
+              <a:t/>
+            </a:r>
+            <a:endParaRPr/>
+          </a:p>
+          <a:p>
+            <a:pPr indent="0" lvl="0" marL="0" rtl="0" algn="l">
+              <a:spcBef>
+                <a:spcPts val="0"/>
+              </a:spcBef>
+              <a:spcAft>
+                <a:spcPts val="0"/>
+              </a:spcAft>
+              <a:buNone/>
+            </a:pPr>
+            <a:r>
+              <a:rPr lang="en-US"/>
+              <a:t/>
+            </a:r>
+            <a:endParaRPr/>
+          </a:p>
+          <a:p>
+            <a:pPr indent="0" lvl="0" marL="0" rtl="0" algn="l">
+              <a:spcBef>
+                <a:spcPts val="0"/>
+              </a:spcBef>
+              <a:spcAft>
+                <a:spcPts val="0"/>
+              </a:spcAft>
+              <a:buNone/>
+            </a:pPr>
+            <a:r>
+              <a:t/>
+            </a:r>
+            <a:endParaRPr/>
+          </a:p>
+          <a:p>
+            <a:pPr indent="0" lvl="0" marL="0" rtl="0" algn="l">
+              <a:spcBef>
+                <a:spcPts val="0"/>
+              </a:spcBef>
+              <a:spcAft>
+                <a:spcPts val="0"/>
+              </a:spcAft>
+              <a:buNone/>
+            </a:pPr>
+            <a:r>
+              <a:rPr lang="en-US"/>
+              <a:t/>
+            </a:r>
+            <a:endParaRPr/>
+          </a:p>
+          <a:p>
+            <a:pPr indent="0" lvl="0" marL="0" rtl="0" algn="l">
+              <a:spcBef>
+                <a:spcPts val="0"/>
+              </a:spcBef>
+              <a:spcAft>
+                <a:spcPts val="0"/>
+              </a:spcAft>
+              <a:buNone/>
+            </a:pPr>
+            <a:r>
+              <a:t/>
+            </a:r>
+            <a:endParaRPr/>
+          </a:p>
+          <a:p>
+            <a:pPr indent="0" lvl="0" marL="0" rtl="0" algn="l">
+              <a:spcBef>
+                <a:spcPts val="0"/>
+              </a:spcBef>
+              <a:spcAft>
+                <a:spcPts val="0"/>
+              </a:spcAft>
+              <a:buNone/>
+            </a:pPr>
+            <a:r>
+              <a:rPr lang="en-US"/>
+              <a:t/>
+            </a:r>
+            <a:endParaRPr/>
+          </a:p>
+          <a:p>
+            <a:pPr indent="0" lvl="0" marL="0" rtl="0" algn="l">
+              <a:spcBef>
+                <a:spcPts val="0"/>
+              </a:spcBef>
+              <a:spcAft>
+                <a:spcPts val="0"/>
+              </a:spcAft>
+              <a:buNone/>
+            </a:pPr>
+            <a:r>
+              <a:t/>
+            </a:r>
+            <a:endParaRPr/>
+          </a:p>
+          <a:p>
+            <a:pPr indent="0" lvl="0" marL="0" rtl="0" algn="l">
+              <a:spcBef>
+                <a:spcPts val="0"/>
+              </a:spcBef>
+              <a:spcAft>
+                <a:spcPts val="0"/>
+              </a:spcAft>
+              <a:buNone/>
+            </a:pPr>
+            <a:r>
+              <a:rPr lang="en-US"/>
+              <a:t/>
+            </a:r>
+            <a:endParaRPr/>
+          </a:p>
+          <a:p>
+            <a:pPr indent="0" lvl="0" marL="0" rtl="0" algn="l">
+              <a:spcBef>
+                <a:spcPts val="0"/>
+              </a:spcBef>
+              <a:spcAft>
+                <a:spcPts val="0"/>
+              </a:spcAft>
+              <a:buNone/>
+            </a:pPr>
+            <a:r>
+              <a:t/>
+            </a:r>
+            <a:endParaRPr/>
+          </a:p>
+          <a:p>
+            <a:pPr indent="0" lvl="0" marL="0" rtl="0" algn="l">
+              <a:spcBef>
+                <a:spcPts val="0"/>
+              </a:spcBef>
+              <a:spcAft>
+                <a:spcPts val="0"/>
+              </a:spcAft>
+              <a:buNone/>
+            </a:pPr>
+            <a:r>
+              <a:rPr lang="en-US"/>
+              <a:t/>
             </a:r>
             <a:endParaRPr/>
           </a:p>
@@ -7200,131 +7200,131 @@
             </a:pPr>
             <a:r>
               <a:rPr lang="en-US"/>
-              <a:t>S10 · 06/15 · fragmentos y embeddings.</a:t>
-            </a:r>
-            <a:endParaRPr/>
-          </a:p>
-          <a:p>
-            <a:pPr indent="0" lvl="0" marL="0" rtl="0" algn="l">
-              <a:spcBef>
-                <a:spcPts val="0"/>
-              </a:spcBef>
-              <a:spcAft>
-                <a:spcPts val="0"/>
-              </a:spcAft>
-              <a:buNone/>
-            </a:pPr>
-            <a:r>
-              <a:t/>
-            </a:r>
-            <a:endParaRPr/>
-          </a:p>
-          <a:p>
-            <a:pPr indent="0" lvl="0" marL="0" rtl="0" algn="l">
-              <a:spcBef>
-                <a:spcPts val="0"/>
-              </a:spcBef>
-              <a:spcAft>
-                <a:spcPts val="0"/>
-              </a:spcAft>
-              <a:buNone/>
-            </a:pPr>
-            <a:r>
-              <a:rPr lang="en-US"/>
-              <a:t>Ejemplo real: c3a59a406888b:s05-langgraph:00.</a:t>
-            </a:r>
-            <a:endParaRPr/>
-          </a:p>
-          <a:p>
-            <a:pPr indent="0" lvl="0" marL="0" rtl="0" algn="l">
-              <a:spcBef>
-                <a:spcPts val="0"/>
-              </a:spcBef>
-              <a:spcAft>
-                <a:spcPts val="0"/>
-              </a:spcAft>
-              <a:buNone/>
-            </a:pPr>
-            <a:r>
-              <a:t/>
-            </a:r>
-            <a:endParaRPr/>
-          </a:p>
-          <a:p>
-            <a:pPr indent="0" lvl="0" marL="0" rtl="0" algn="l">
-              <a:spcBef>
-                <a:spcPts val="0"/>
-              </a:spcBef>
-              <a:spcAft>
-                <a:spcPts val="0"/>
-              </a:spcAft>
-              <a:buNone/>
-            </a:pPr>
-            <a:r>
-              <a:rPr lang="en-US"/>
-              <a:t>vectorIdFor devuelve ese id si cabe en 64 bytes. Está en packages/rag/src/ids.ts.</a:t>
-            </a:r>
-            <a:endParaRPr/>
-          </a:p>
-          <a:p>
-            <a:pPr indent="0" lvl="0" marL="0" rtl="0" algn="l">
-              <a:spcBef>
-                <a:spcPts val="0"/>
-              </a:spcBef>
-              <a:spcAft>
-                <a:spcPts val="0"/>
-              </a:spcAft>
-              <a:buNone/>
-            </a:pPr>
-            <a:r>
-              <a:t/>
-            </a:r>
-            <a:endParaRPr/>
-          </a:p>
-          <a:p>
-            <a:pPr indent="0" lvl="0" marL="0" rtl="0" algn="l">
-              <a:spcBef>
-                <a:spcPts val="0"/>
-              </a:spcBef>
-              <a:spcAft>
-                <a:spcPts val="0"/>
-              </a:spcAft>
-              <a:buNone/>
-            </a:pPr>
-            <a:r>
-              <a:rPr lang="en-US"/>
-              <a:t>El perfil demo es fixture-token-hash-v1, 128 dimensiones, coseno, umbral 0,33.</a:t>
-            </a:r>
-            <a:endParaRPr/>
-          </a:p>
-          <a:p>
-            <a:pPr indent="0" lvl="0" marL="0" rtl="0" algn="l">
-              <a:spcBef>
-                <a:spcPts val="0"/>
-              </a:spcBef>
-              <a:spcAft>
-                <a:spcPts val="0"/>
-              </a:spcAft>
-              <a:buNone/>
-            </a:pPr>
-            <a:r>
-              <a:t/>
-            </a:r>
-            <a:endParaRPr/>
-          </a:p>
-          <a:p>
-            <a:pPr indent="0" lvl="0" marL="0" rtl="0" algn="l">
-              <a:spcBef>
-                <a:spcPts val="0"/>
-              </a:spcBef>
-              <a:spcAft>
-                <a:spcPts val="0"/>
-              </a:spcAft>
-              <a:buNone/>
-            </a:pPr>
-            <a:r>
-              <a:rPr lang="en-US"/>
-              <a:t>Di: 0,33 no es un umbral de BGE-M3. 128 no es la dimensión observada del modelo.</a:t>
+              <a:t>S10 · 06/15 · bloque 10–25 min. Funcionamiento del embedding e índice vectorial. El documento y la pregunta deben usar exactamente el mismo modelo y dimensión (768 en lab/schema.sql con EMBEDDING_MODEL_ID y vector(768) + índice HNSW m=16, ef_construction=64; 1024 en BGE-M3 del demostrador). Explica la escala: en pgvector el operador &lt;=&gt; es distancia coseno en [0, 2] donde menor significa más próximo; 1 - distancia es la similitud coseno.</a:t>
+            </a:r>
+            <a:endParaRPr/>
+          </a:p>
+          <a:p>
+            <a:pPr indent="0" lvl="0" marL="0" rtl="0" algn="l">
+              <a:spcBef>
+                <a:spcPts val="0"/>
+              </a:spcBef>
+              <a:spcAft>
+                <a:spcPts val="0"/>
+              </a:spcAft>
+              <a:buNone/>
+            </a:pPr>
+            <a:r>
+              <a:t/>
+            </a:r>
+            <a:endParaRPr/>
+          </a:p>
+          <a:p>
+            <a:pPr indent="0" lvl="0" marL="0" rtl="0" algn="l">
+              <a:spcBef>
+                <a:spcPts val="0"/>
+              </a:spcBef>
+              <a:spcAft>
+                <a:spcPts val="0"/>
+              </a:spcAft>
+              <a:buNone/>
+            </a:pPr>
+            <a:r>
+              <a:rPr lang="en-US"/>
+              <a:t/>
+            </a:r>
+            <a:endParaRPr/>
+          </a:p>
+          <a:p>
+            <a:pPr indent="0" lvl="0" marL="0" rtl="0" algn="l">
+              <a:spcBef>
+                <a:spcPts val="0"/>
+              </a:spcBef>
+              <a:spcAft>
+                <a:spcPts val="0"/>
+              </a:spcAft>
+              <a:buNone/>
+            </a:pPr>
+            <a:r>
+              <a:t/>
+            </a:r>
+            <a:endParaRPr/>
+          </a:p>
+          <a:p>
+            <a:pPr indent="0" lvl="0" marL="0" rtl="0" algn="l">
+              <a:spcBef>
+                <a:spcPts val="0"/>
+              </a:spcBef>
+              <a:spcAft>
+                <a:spcPts val="0"/>
+              </a:spcAft>
+              <a:buNone/>
+            </a:pPr>
+            <a:r>
+              <a:rPr lang="en-US"/>
+              <a:t/>
+            </a:r>
+            <a:endParaRPr/>
+          </a:p>
+          <a:p>
+            <a:pPr indent="0" lvl="0" marL="0" rtl="0" algn="l">
+              <a:spcBef>
+                <a:spcPts val="0"/>
+              </a:spcBef>
+              <a:spcAft>
+                <a:spcPts val="0"/>
+              </a:spcAft>
+              <a:buNone/>
+            </a:pPr>
+            <a:r>
+              <a:t/>
+            </a:r>
+            <a:endParaRPr/>
+          </a:p>
+          <a:p>
+            <a:pPr indent="0" lvl="0" marL="0" rtl="0" algn="l">
+              <a:spcBef>
+                <a:spcPts val="0"/>
+              </a:spcBef>
+              <a:spcAft>
+                <a:spcPts val="0"/>
+              </a:spcAft>
+              <a:buNone/>
+            </a:pPr>
+            <a:r>
+              <a:rPr lang="en-US"/>
+              <a:t/>
+            </a:r>
+            <a:endParaRPr/>
+          </a:p>
+          <a:p>
+            <a:pPr indent="0" lvl="0" marL="0" rtl="0" algn="l">
+              <a:spcBef>
+                <a:spcPts val="0"/>
+              </a:spcBef>
+              <a:spcAft>
+                <a:spcPts val="0"/>
+              </a:spcAft>
+              <a:buNone/>
+            </a:pPr>
+            <a:r>
+              <a:t/>
+            </a:r>
+            <a:endParaRPr/>
+          </a:p>
+          <a:p>
+            <a:pPr indent="0" lvl="0" marL="0" rtl="0" algn="l">
+              <a:spcBef>
+                <a:spcPts val="0"/>
+              </a:spcBef>
+              <a:spcAft>
+                <a:spcPts val="0"/>
+              </a:spcAft>
+              <a:buNone/>
+            </a:pPr>
+            <a:r>
+              <a:rPr lang="en-US"/>
+              <a:t/>
             </a:r>
             <a:endParaRPr/>
           </a:p>
@@ -7923,131 +7923,131 @@
             </a:pPr>
             <a:r>
               <a:rPr lang="en-US"/>
-              <a:t>S10 · 09/15 · bloque 40–60. Respuesta y citas.</a:t>
-            </a:r>
-            <a:endParaRPr/>
-          </a:p>
-          <a:p>
-            <a:pPr indent="0" lvl="0" marL="0" rtl="0" algn="l">
-              <a:spcBef>
-                <a:spcPts val="0"/>
-              </a:spcBef>
-              <a:spcAft>
-                <a:spcPts val="0"/>
-              </a:spcAft>
-              <a:buNone/>
-            </a:pPr>
-            <a:r>
-              <a:t/>
-            </a:r>
-            <a:endParaRPr/>
-          </a:p>
-          <a:p>
-            <a:pPr indent="0" lvl="0" marL="0" rtl="0" algn="l">
-              <a:spcBef>
-                <a:spcPts val="0"/>
-              </a:spcBef>
-              <a:spcAft>
-                <a:spcPts val="0"/>
-              </a:spcAft>
-              <a:buNone/>
-            </a:pPr>
-            <a:r>
-              <a:rPr lang="en-US"/>
-              <a:t>La respuesta demo empieza por: Respuesta de la canalización local de prueba.</a:t>
-            </a:r>
-            <a:endParaRPr/>
-          </a:p>
-          <a:p>
-            <a:pPr indent="0" lvl="0" marL="0" rtl="0" algn="l">
-              <a:spcBef>
-                <a:spcPts val="0"/>
-              </a:spcBef>
-              <a:spcAft>
-                <a:spcPts val="0"/>
-              </a:spcAft>
-              <a:buNone/>
-            </a:pPr>
-            <a:r>
-              <a:t/>
-            </a:r>
-            <a:endParaRPr/>
-          </a:p>
-          <a:p>
-            <a:pPr indent="0" lvl="0" marL="0" rtl="0" algn="l">
-              <a:spcBef>
-                <a:spcPts val="0"/>
-              </a:spcBef>
-              <a:spcAft>
-                <a:spcPts val="0"/>
-              </a:spcAft>
-              <a:buNone/>
-            </a:pPr>
-            <a:r>
-              <a:rPr lang="en-US"/>
-              <a:t>La cita tiene la forma [cite:id]. El panel Fuentes muestra título, sección, chunkId y corpus.</a:t>
-            </a:r>
-            <a:endParaRPr/>
-          </a:p>
-          <a:p>
-            <a:pPr indent="0" lvl="0" marL="0" rtl="0" algn="l">
-              <a:spcBef>
-                <a:spcPts val="0"/>
-              </a:spcBef>
-              <a:spcAft>
-                <a:spcPts val="0"/>
-              </a:spcAft>
-              <a:buNone/>
-            </a:pPr>
-            <a:r>
-              <a:t/>
-            </a:r>
-            <a:endParaRPr/>
-          </a:p>
-          <a:p>
-            <a:pPr indent="0" lvl="0" marL="0" rtl="0" algn="l">
-              <a:spcBef>
-                <a:spcPts val="0"/>
-              </a:spcBef>
-              <a:spcAft>
-                <a:spcPts val="0"/>
-              </a:spcAft>
-              <a:buNone/>
-            </a:pPr>
-            <a:r>
-              <a:rPr lang="en-US"/>
-              <a:t>Esa cita no sale de un modelo. Es el texto del fragmento recuperado.</a:t>
-            </a:r>
-            <a:endParaRPr/>
-          </a:p>
-          <a:p>
-            <a:pPr indent="0" lvl="0" marL="0" rtl="0" algn="l">
-              <a:spcBef>
-                <a:spcPts val="0"/>
-              </a:spcBef>
-              <a:spcAft>
-                <a:spcPts val="0"/>
-              </a:spcAft>
-              <a:buNone/>
-            </a:pPr>
-            <a:r>
-              <a:t/>
-            </a:r>
-            <a:endParaRPr/>
-          </a:p>
-          <a:p>
-            <a:pPr indent="0" lvl="0" marL="0" rtl="0" algn="l">
-              <a:spcBef>
-                <a:spcPts val="0"/>
-              </a:spcBef>
-              <a:spcAft>
-                <a:spcPts val="0"/>
-              </a:spcAft>
-              <a:buNone/>
-            </a:pPr>
-            <a:r>
-              <a:rPr lang="en-US"/>
-              <a:t>RAG básico hace una sola búsqueda. La reescritura de seguimiento sigue pendiente.</a:t>
+              <a:t>S10 · 09/15 · bloque 40–60 min. Construcción del contexto, bloque DATOS no fiable y validación de citas [cite:id]. Explica que los fragmentos recuperados se envuelven como datos y nunca como instrucciones del sistema. Después de recorrer el RAG semántico, presenta como variante adicional RAG_CONTEXT_MODE=complete (docs/rag-contexto-completo.md): cuando un corpus es muy pequeño (23 KB) cabe entero en D1, aunque no demuestra el filtro por puntuación del ejercicio.</a:t>
+            </a:r>
+            <a:endParaRPr/>
+          </a:p>
+          <a:p>
+            <a:pPr indent="0" lvl="0" marL="0" rtl="0" algn="l">
+              <a:spcBef>
+                <a:spcPts val="0"/>
+              </a:spcBef>
+              <a:spcAft>
+                <a:spcPts val="0"/>
+              </a:spcAft>
+              <a:buNone/>
+            </a:pPr>
+            <a:r>
+              <a:t/>
+            </a:r>
+            <a:endParaRPr/>
+          </a:p>
+          <a:p>
+            <a:pPr indent="0" lvl="0" marL="0" rtl="0" algn="l">
+              <a:spcBef>
+                <a:spcPts val="0"/>
+              </a:spcBef>
+              <a:spcAft>
+                <a:spcPts val="0"/>
+              </a:spcAft>
+              <a:buNone/>
+            </a:pPr>
+            <a:r>
+              <a:rPr lang="en-US"/>
+              <a:t/>
+            </a:r>
+            <a:endParaRPr/>
+          </a:p>
+          <a:p>
+            <a:pPr indent="0" lvl="0" marL="0" rtl="0" algn="l">
+              <a:spcBef>
+                <a:spcPts val="0"/>
+              </a:spcBef>
+              <a:spcAft>
+                <a:spcPts val="0"/>
+              </a:spcAft>
+              <a:buNone/>
+            </a:pPr>
+            <a:r>
+              <a:t/>
+            </a:r>
+            <a:endParaRPr/>
+          </a:p>
+          <a:p>
+            <a:pPr indent="0" lvl="0" marL="0" rtl="0" algn="l">
+              <a:spcBef>
+                <a:spcPts val="0"/>
+              </a:spcBef>
+              <a:spcAft>
+                <a:spcPts val="0"/>
+              </a:spcAft>
+              <a:buNone/>
+            </a:pPr>
+            <a:r>
+              <a:rPr lang="en-US"/>
+              <a:t/>
+            </a:r>
+            <a:endParaRPr/>
+          </a:p>
+          <a:p>
+            <a:pPr indent="0" lvl="0" marL="0" rtl="0" algn="l">
+              <a:spcBef>
+                <a:spcPts val="0"/>
+              </a:spcBef>
+              <a:spcAft>
+                <a:spcPts val="0"/>
+              </a:spcAft>
+              <a:buNone/>
+            </a:pPr>
+            <a:r>
+              <a:t/>
+            </a:r>
+            <a:endParaRPr/>
+          </a:p>
+          <a:p>
+            <a:pPr indent="0" lvl="0" marL="0" rtl="0" algn="l">
+              <a:spcBef>
+                <a:spcPts val="0"/>
+              </a:spcBef>
+              <a:spcAft>
+                <a:spcPts val="0"/>
+              </a:spcAft>
+              <a:buNone/>
+            </a:pPr>
+            <a:r>
+              <a:rPr lang="en-US"/>
+              <a:t/>
+            </a:r>
+            <a:endParaRPr/>
+          </a:p>
+          <a:p>
+            <a:pPr indent="0" lvl="0" marL="0" rtl="0" algn="l">
+              <a:spcBef>
+                <a:spcPts val="0"/>
+              </a:spcBef>
+              <a:spcAft>
+                <a:spcPts val="0"/>
+              </a:spcAft>
+              <a:buNone/>
+            </a:pPr>
+            <a:r>
+              <a:t/>
+            </a:r>
+            <a:endParaRPr/>
+          </a:p>
+          <a:p>
+            <a:pPr indent="0" lvl="0" marL="0" rtl="0" algn="l">
+              <a:spcBef>
+                <a:spcPts val="0"/>
+              </a:spcBef>
+              <a:spcAft>
+                <a:spcPts val="0"/>
+              </a:spcAft>
+              <a:buNone/>
+            </a:pPr>
+            <a:r>
+              <a:rPr lang="en-US"/>
+              <a:t/>
             </a:r>
             <a:endParaRPr/>
           </a:p>
@@ -8709,131 +8709,131 @@
             </a:pPr>
             <a:r>
               <a:rPr lang="en-US"/>
-              <a:t>S10 · 07/15 · bloque 25–40. Recuperación.</a:t>
-            </a:r>
-            <a:endParaRPr/>
-          </a:p>
-          <a:p>
-            <a:pPr indent="0" lvl="0" marL="0" rtl="0" algn="l">
-              <a:spcBef>
-                <a:spcPts val="0"/>
-              </a:spcBef>
-              <a:spcAft>
-                <a:spcPts val="0"/>
-              </a:spcAft>
-              <a:buNone/>
-            </a:pPr>
-            <a:r>
-              <a:t/>
-            </a:r>
-            <a:endParaRPr/>
-          </a:p>
-          <a:p>
-            <a:pPr indent="0" lvl="0" marL="0" rtl="0" algn="l">
-              <a:spcBef>
-                <a:spcPts val="0"/>
-              </a:spcBef>
-              <a:spcAft>
-                <a:spcPts val="0"/>
-              </a:spcAft>
-              <a:buNone/>
-            </a:pPr>
-            <a:r>
-              <a:rPr lang="en-US"/>
-              <a:t>Cambia a RAG básico. La conversación se vacía.</a:t>
-            </a:r>
-            <a:endParaRPr/>
-          </a:p>
-          <a:p>
-            <a:pPr indent="0" lvl="0" marL="0" rtl="0" algn="l">
-              <a:spcBef>
-                <a:spcPts val="0"/>
-              </a:spcBef>
-              <a:spcAft>
-                <a:spcPts val="0"/>
-              </a:spcAft>
-              <a:buNone/>
-            </a:pPr>
-            <a:r>
-              <a:t/>
-            </a:r>
-            <a:endParaRPr/>
-          </a:p>
-          <a:p>
-            <a:pPr indent="0" lvl="0" marL="0" rtl="0" algn="l">
-              <a:spcBef>
-                <a:spcPts val="0"/>
-              </a:spcBef>
-              <a:spcAft>
-                <a:spcPts val="0"/>
-              </a:spcAft>
-              <a:buNone/>
-            </a:pPr>
-            <a:r>
-              <a:rPr lang="en-US"/>
-              <a:t>Pregunta de calendario en General: debe pedir L/X o M/J y no mostrar las dos fechas.</a:t>
-            </a:r>
-            <a:endParaRPr/>
-          </a:p>
-          <a:p>
-            <a:pPr indent="0" lvl="0" marL="0" rtl="0" algn="l">
-              <a:spcBef>
-                <a:spcPts val="0"/>
-              </a:spcBef>
-              <a:spcAft>
-                <a:spcPts val="0"/>
-              </a:spcAft>
-              <a:buNone/>
-            </a:pPr>
-            <a:r>
-              <a:t/>
-            </a:r>
-            <a:endParaRPr/>
-          </a:p>
-          <a:p>
-            <a:pPr indent="0" lvl="0" marL="0" rtl="0" algn="l">
-              <a:spcBef>
-                <a:spcPts val="0"/>
-              </a:spcBef>
-              <a:spcAft>
-                <a:spcPts val="0"/>
-              </a:spcAft>
-              <a:buNone/>
-            </a:pPr>
-            <a:r>
-              <a:rPr lang="en-US"/>
-              <a:t>En M/J, la clase de RAG S10 debe mostrar 2026-10-22 y no 2026-10-26.</a:t>
-            </a:r>
-            <a:endParaRPr/>
-          </a:p>
-          <a:p>
-            <a:pPr indent="0" lvl="0" marL="0" rtl="0" algn="l">
-              <a:spcBef>
-                <a:spcPts val="0"/>
-              </a:spcBef>
-              <a:spcAft>
-                <a:spcPts val="0"/>
-              </a:spcAft>
-              <a:buNone/>
-            </a:pPr>
-            <a:r>
-              <a:t/>
-            </a:r>
-            <a:endParaRPr/>
-          </a:p>
-          <a:p>
-            <a:pPr indent="0" lvl="0" marL="0" rtl="0" algn="l">
-              <a:spcBef>
-                <a:spcPts val="0"/>
-              </a:spcBef>
-              <a:spcAft>
-                <a:spcPts val="0"/>
-              </a:spcAft>
-              <a:buNone/>
-            </a:pPr>
-            <a:r>
-              <a:rPr lang="en-US"/>
-              <a:t>La puntuación del panel es un coseno lexical. No la llames probabilidad ni relevancia de Vectorize.</a:t>
+              <a:t>S10 · 07/15 · bloque 25–40 min. Recorrido semántico de consulta (RAG_CONTEXT_MODE=semantic en apps/api/src/app.ts:670 y runLabBasicRag en lab/src/rag-basic.ts): 1) embeber la pregunta, 2) filtrar por metadatos/audiencia en el índice antes de leer, 3) ordenar candidatos por distancia/similitud, 4) aplicar el umbral calibrado y 5) construir el contexto.</a:t>
+            </a:r>
+            <a:endParaRPr/>
+          </a:p>
+          <a:p>
+            <a:pPr indent="0" lvl="0" marL="0" rtl="0" algn="l">
+              <a:spcBef>
+                <a:spcPts val="0"/>
+              </a:spcBef>
+              <a:spcAft>
+                <a:spcPts val="0"/>
+              </a:spcAft>
+              <a:buNone/>
+            </a:pPr>
+            <a:r>
+              <a:t/>
+            </a:r>
+            <a:endParaRPr/>
+          </a:p>
+          <a:p>
+            <a:pPr indent="0" lvl="0" marL="0" rtl="0" algn="l">
+              <a:spcBef>
+                <a:spcPts val="0"/>
+              </a:spcBef>
+              <a:spcAft>
+                <a:spcPts val="0"/>
+              </a:spcAft>
+              <a:buNone/>
+            </a:pPr>
+            <a:r>
+              <a:rPr lang="en-US"/>
+              <a:t/>
+            </a:r>
+            <a:endParaRPr/>
+          </a:p>
+          <a:p>
+            <a:pPr indent="0" lvl="0" marL="0" rtl="0" algn="l">
+              <a:spcBef>
+                <a:spcPts val="0"/>
+              </a:spcBef>
+              <a:spcAft>
+                <a:spcPts val="0"/>
+              </a:spcAft>
+              <a:buNone/>
+            </a:pPr>
+            <a:r>
+              <a:t/>
+            </a:r>
+            <a:endParaRPr/>
+          </a:p>
+          <a:p>
+            <a:pPr indent="0" lvl="0" marL="0" rtl="0" algn="l">
+              <a:spcBef>
+                <a:spcPts val="0"/>
+              </a:spcBef>
+              <a:spcAft>
+                <a:spcPts val="0"/>
+              </a:spcAft>
+              <a:buNone/>
+            </a:pPr>
+            <a:r>
+              <a:rPr lang="en-US"/>
+              <a:t/>
+            </a:r>
+            <a:endParaRPr/>
+          </a:p>
+          <a:p>
+            <a:pPr indent="0" lvl="0" marL="0" rtl="0" algn="l">
+              <a:spcBef>
+                <a:spcPts val="0"/>
+              </a:spcBef>
+              <a:spcAft>
+                <a:spcPts val="0"/>
+              </a:spcAft>
+              <a:buNone/>
+            </a:pPr>
+            <a:r>
+              <a:t/>
+            </a:r>
+            <a:endParaRPr/>
+          </a:p>
+          <a:p>
+            <a:pPr indent="0" lvl="0" marL="0" rtl="0" algn="l">
+              <a:spcBef>
+                <a:spcPts val="0"/>
+              </a:spcBef>
+              <a:spcAft>
+                <a:spcPts val="0"/>
+              </a:spcAft>
+              <a:buNone/>
+            </a:pPr>
+            <a:r>
+              <a:rPr lang="en-US"/>
+              <a:t/>
+            </a:r>
+            <a:endParaRPr/>
+          </a:p>
+          <a:p>
+            <a:pPr indent="0" lvl="0" marL="0" rtl="0" algn="l">
+              <a:spcBef>
+                <a:spcPts val="0"/>
+              </a:spcBef>
+              <a:spcAft>
+                <a:spcPts val="0"/>
+              </a:spcAft>
+              <a:buNone/>
+            </a:pPr>
+            <a:r>
+              <a:t/>
+            </a:r>
+            <a:endParaRPr/>
+          </a:p>
+          <a:p>
+            <a:pPr indent="0" lvl="0" marL="0" rtl="0" algn="l">
+              <a:spcBef>
+                <a:spcPts val="0"/>
+              </a:spcBef>
+              <a:spcAft>
+                <a:spcPts val="0"/>
+              </a:spcAft>
+              <a:buNone/>
+            </a:pPr>
+            <a:r>
+              <a:rPr lang="en-US"/>
+              <a:t/>
             </a:r>
             <a:endParaRPr/>
           </a:p>
@@ -9902,131 +9902,131 @@
             </a:pPr>
             <a:r>
               <a:rPr lang="en-US"/>
-              <a:t>S10 · 04/15 · bloque 10–25. Corpus.</a:t>
-            </a:r>
-            <a:endParaRPr/>
-          </a:p>
-          <a:p>
-            <a:pPr indent="0" lvl="0" marL="0" rtl="0" algn="l">
-              <a:spcBef>
-                <a:spcPts val="0"/>
-              </a:spcBef>
-              <a:spcAft>
-                <a:spcPts val="0"/>
-              </a:spcAft>
-              <a:buNone/>
-            </a:pPr>
-            <a:r>
-              <a:t/>
-            </a:r>
-            <a:endParaRPr/>
-          </a:p>
-          <a:p>
-            <a:pPr indent="0" lvl="0" marL="0" rtl="0" algn="l">
-              <a:spcBef>
-                <a:spcPts val="0"/>
-              </a:spcBef>
-              <a:spcAft>
-                <a:spcPts val="0"/>
-              </a:spcAft>
-              <a:buNone/>
-            </a:pPr>
-            <a:r>
-              <a:rPr lang="en-US"/>
-              <a:t>Abre corpus/COVERAGE.md y el banner de la app.</a:t>
-            </a:r>
-            <a:endParaRPr/>
-          </a:p>
-          <a:p>
-            <a:pPr indent="0" lvl="0" marL="0" rtl="0" algn="l">
-              <a:spcBef>
-                <a:spcPts val="0"/>
-              </a:spcBef>
-              <a:spcAft>
-                <a:spcPts val="0"/>
-              </a:spcAft>
-              <a:buNone/>
-            </a:pPr>
-            <a:r>
-              <a:t/>
-            </a:r>
-            <a:endParaRPr/>
-          </a:p>
-          <a:p>
-            <a:pPr indent="0" lvl="0" marL="0" rtl="0" algn="l">
-              <a:spcBef>
-                <a:spcPts val="0"/>
-              </a:spcBef>
-              <a:spcAft>
-                <a:spcPts val="0"/>
-              </a:spcAft>
-              <a:buNone/>
-            </a:pPr>
-            <a:r>
-              <a:rPr lang="en-US"/>
-              <a:t>Preparación c3a59a406888b. Contenido cc037ef0bb1f7. Perfil p9e8e8e03627e, fixture.</a:t>
-            </a:r>
-            <a:endParaRPr/>
-          </a:p>
-          <a:p>
-            <a:pPr indent="0" lvl="0" marL="0" rtl="0" algn="l">
-              <a:spcBef>
-                <a:spcPts val="0"/>
-              </a:spcBef>
-              <a:spcAft>
-                <a:spcPts val="0"/>
-              </a:spcAft>
-              <a:buNone/>
-            </a:pPr>
-            <a:r>
-              <a:t/>
-            </a:r>
-            <a:endParaRPr/>
-          </a:p>
-          <a:p>
-            <a:pPr indent="0" lvl="0" marL="0" rtl="0" algn="l">
-              <a:spcBef>
-                <a:spcPts val="0"/>
-              </a:spcBef>
-              <a:spcAft>
-                <a:spcPts val="0"/>
-              </a:spcAft>
-              <a:buNone/>
-            </a:pPr>
-            <a:r>
-              <a:rPr lang="en-US"/>
-              <a:t>Temario y calendarios completos. Ejercicios parciales: 12 resúmenes y 8 solo título.</a:t>
-            </a:r>
-            <a:endParaRPr/>
-          </a:p>
-          <a:p>
-            <a:pPr indent="0" lvl="0" marL="0" rtl="0" algn="l">
-              <a:spcBef>
-                <a:spcPts val="0"/>
-              </a:spcBef>
-              <a:spcAft>
-                <a:spcPts val="0"/>
-              </a:spcAft>
-              <a:buNone/>
-            </a:pPr>
-            <a:r>
-              <a:t/>
-            </a:r>
-            <a:endParaRPr/>
-          </a:p>
-          <a:p>
-            <a:pPr indent="0" lvl="0" marL="0" rtl="0" algn="l">
-              <a:spcBef>
-                <a:spcPts val="0"/>
-              </a:spcBef>
-              <a:spcAft>
-                <a:spcPts val="0"/>
-              </a:spcAft>
-              <a:buNone/>
-            </a:pPr>
-            <a:r>
-              <a:rPr lang="en-US"/>
-              <a:t>M/J S10 es el 22 de octubre. L/X S10 es el 26. No copies una fecha a la otra cohorte.</a:t>
+              <a:t>S10 · 11/15 · bloque 60–75 min. Reconstrucción desde índice vacío y protocolo de evaluación. En lab/, bun run lab:rebuild ejecuta TRUNCATE, lee los 10 documentos en bruto, genera los vectores de 768 d, los inserta y comprueba la lectura de vuelta. bun run lab:eval ejecuta las 20 preguntas de test (14 respondibles y 6 sin respuesta) sin reajustar el umbral.</a:t>
+            </a:r>
+            <a:endParaRPr/>
+          </a:p>
+          <a:p>
+            <a:pPr indent="0" lvl="0" marL="0" rtl="0" algn="l">
+              <a:spcBef>
+                <a:spcPts val="0"/>
+              </a:spcBef>
+              <a:spcAft>
+                <a:spcPts val="0"/>
+              </a:spcAft>
+              <a:buNone/>
+            </a:pPr>
+            <a:r>
+              <a:t/>
+            </a:r>
+            <a:endParaRPr/>
+          </a:p>
+          <a:p>
+            <a:pPr indent="0" lvl="0" marL="0" rtl="0" algn="l">
+              <a:spcBef>
+                <a:spcPts val="0"/>
+              </a:spcBef>
+              <a:spcAft>
+                <a:spcPts val="0"/>
+              </a:spcAft>
+              <a:buNone/>
+            </a:pPr>
+            <a:r>
+              <a:rPr lang="en-US"/>
+              <a:t/>
+            </a:r>
+            <a:endParaRPr/>
+          </a:p>
+          <a:p>
+            <a:pPr indent="0" lvl="0" marL="0" rtl="0" algn="l">
+              <a:spcBef>
+                <a:spcPts val="0"/>
+              </a:spcBef>
+              <a:spcAft>
+                <a:spcPts val="0"/>
+              </a:spcAft>
+              <a:buNone/>
+            </a:pPr>
+            <a:r>
+              <a:t/>
+            </a:r>
+            <a:endParaRPr/>
+          </a:p>
+          <a:p>
+            <a:pPr indent="0" lvl="0" marL="0" rtl="0" algn="l">
+              <a:spcBef>
+                <a:spcPts val="0"/>
+              </a:spcBef>
+              <a:spcAft>
+                <a:spcPts val="0"/>
+              </a:spcAft>
+              <a:buNone/>
+            </a:pPr>
+            <a:r>
+              <a:rPr lang="en-US"/>
+              <a:t/>
+            </a:r>
+            <a:endParaRPr/>
+          </a:p>
+          <a:p>
+            <a:pPr indent="0" lvl="0" marL="0" rtl="0" algn="l">
+              <a:spcBef>
+                <a:spcPts val="0"/>
+              </a:spcBef>
+              <a:spcAft>
+                <a:spcPts val="0"/>
+              </a:spcAft>
+              <a:buNone/>
+            </a:pPr>
+            <a:r>
+              <a:t/>
+            </a:r>
+            <a:endParaRPr/>
+          </a:p>
+          <a:p>
+            <a:pPr indent="0" lvl="0" marL="0" rtl="0" algn="l">
+              <a:spcBef>
+                <a:spcPts val="0"/>
+              </a:spcBef>
+              <a:spcAft>
+                <a:spcPts val="0"/>
+              </a:spcAft>
+              <a:buNone/>
+            </a:pPr>
+            <a:r>
+              <a:rPr lang="en-US"/>
+              <a:t/>
+            </a:r>
+            <a:endParaRPr/>
+          </a:p>
+          <a:p>
+            <a:pPr indent="0" lvl="0" marL="0" rtl="0" algn="l">
+              <a:spcBef>
+                <a:spcPts val="0"/>
+              </a:spcBef>
+              <a:spcAft>
+                <a:spcPts val="0"/>
+              </a:spcAft>
+              <a:buNone/>
+            </a:pPr>
+            <a:r>
+              <a:t/>
+            </a:r>
+            <a:endParaRPr/>
+          </a:p>
+          <a:p>
+            <a:pPr indent="0" lvl="0" marL="0" rtl="0" algn="l">
+              <a:spcBef>
+                <a:spcPts val="0"/>
+              </a:spcBef>
+              <a:spcAft>
+                <a:spcPts val="0"/>
+              </a:spcAft>
+              <a:buNone/>
+            </a:pPr>
+            <a:r>
+              <a:rPr lang="en-US"/>
+              <a:t/>
             </a:r>
             <a:endParaRPr/>
           </a:p>
@@ -11095,131 +11095,131 @@
             </a:pPr>
             <a:r>
               <a:rPr lang="en-US"/>
-              <a:t>S10 · 05/15 · bloque 10–25, preparación frente a consulta.</a:t>
-            </a:r>
-            <a:endParaRPr/>
-          </a:p>
-          <a:p>
-            <a:pPr indent="0" lvl="0" marL="0" rtl="0" algn="l">
-              <a:spcBef>
-                <a:spcPts val="0"/>
-              </a:spcBef>
-              <a:spcAft>
-                <a:spcPts val="0"/>
-              </a:spcAft>
-              <a:buNone/>
-            </a:pPr>
-            <a:r>
-              <a:t/>
-            </a:r>
-            <a:endParaRPr/>
-          </a:p>
-          <a:p>
-            <a:pPr indent="0" lvl="0" marL="0" rtl="0" algn="l">
-              <a:spcBef>
-                <a:spcPts val="0"/>
-              </a:spcBef>
-              <a:spcAft>
-                <a:spcPts val="0"/>
-              </a:spcAft>
-              <a:buNone/>
-            </a:pPr>
-            <a:r>
-              <a:rPr lang="en-US"/>
-              <a:t>El puente TypeScript: una plantilla `${v}:${doc}:${o}` equivale a un f-string de Python.</a:t>
-            </a:r>
-            <a:endParaRPr/>
-          </a:p>
-          <a:p>
-            <a:pPr indent="0" lvl="0" marL="0" rtl="0" algn="l">
-              <a:spcBef>
-                <a:spcPts val="0"/>
-              </a:spcBef>
-              <a:spcAft>
-                <a:spcPts val="0"/>
-              </a:spcAft>
-              <a:buNone/>
-            </a:pPr>
-            <a:r>
-              <a:t/>
-            </a:r>
-            <a:endParaRPr/>
-          </a:p>
-          <a:p>
-            <a:pPr indent="0" lvl="0" marL="0" rtl="0" algn="l">
-              <a:spcBef>
-                <a:spcPts val="0"/>
-              </a:spcBef>
-              <a:spcAft>
-                <a:spcPts val="0"/>
-              </a:spcAft>
-              <a:buNone/>
-            </a:pPr>
-            <a:r>
-              <a:rPr lang="en-US"/>
-              <a:t>chunkId está en packages/rag/src/chunk.ts. No reescribas el proyecto en Python.</a:t>
-            </a:r>
-            <a:endParaRPr/>
-          </a:p>
-          <a:p>
-            <a:pPr indent="0" lvl="0" marL="0" rtl="0" algn="l">
-              <a:spcBef>
-                <a:spcPts val="0"/>
-              </a:spcBef>
-              <a:spcAft>
-                <a:spcPts val="0"/>
-              </a:spcAft>
-              <a:buNone/>
-            </a:pPr>
-            <a:r>
-              <a:t/>
-            </a:r>
-            <a:endParaRPr/>
-          </a:p>
-          <a:p>
-            <a:pPr indent="0" lvl="0" marL="0" rtl="0" algn="l">
-              <a:spcBef>
-                <a:spcPts val="0"/>
-              </a:spcBef>
-              <a:spcAft>
-                <a:spcPts val="0"/>
-              </a:spcAft>
-              <a:buNone/>
-            </a:pPr>
-            <a:r>
-              <a:rPr lang="en-US"/>
-              <a:t>corpus.json no trae el cuerpo. La ingesta lo lee de corpus/sources y comprueba sourceHash.</a:t>
-            </a:r>
-            <a:endParaRPr/>
-          </a:p>
-          <a:p>
-            <a:pPr indent="0" lvl="0" marL="0" rtl="0" algn="l">
-              <a:spcBef>
-                <a:spcPts val="0"/>
-              </a:spcBef>
-              <a:spcAft>
-                <a:spcPts val="0"/>
-              </a:spcAft>
-              <a:buNone/>
-            </a:pPr>
-            <a:r>
-              <a:t/>
-            </a:r>
-            <a:endParaRPr/>
-          </a:p>
-          <a:p>
-            <a:pPr indent="0" lvl="0" marL="0" rtl="0" algn="l">
-              <a:spcBef>
-                <a:spcPts val="0"/>
-              </a:spcBef>
-              <a:spcAft>
-                <a:spcPts val="0"/>
-              </a:spcAft>
-              <a:buNone/>
-            </a:pPr>
-            <a:r>
-              <a:rPr lang="en-US"/>
-              <a:t>Hoy en clase no ejecutes la ingesta remota.</a:t>
+              <a:t>S10 · 04/15 · bloque 10–25 min. Corpus y perfiles verificados. En el demostrador del curso: preparación c3a59a406888b (22 documentos, 69 fragmentos) y perfil activo p76509a5f9743 (BGE-M3, 1024 dimensiones, coseno, umbral 0,50). En el laboratorio del ejercicio (lab/): 10 documentos ficticios de AetherCloud (lab-689164ca81cd, 20 fragmentos) sobre PostgreSQL + pgvector con vector(768) e índice HNSW.</a:t>
+            </a:r>
+            <a:endParaRPr/>
+          </a:p>
+          <a:p>
+            <a:pPr indent="0" lvl="0" marL="0" rtl="0" algn="l">
+              <a:spcBef>
+                <a:spcPts val="0"/>
+              </a:spcBef>
+              <a:spcAft>
+                <a:spcPts val="0"/>
+              </a:spcAft>
+              <a:buNone/>
+            </a:pPr>
+            <a:r>
+              <a:t/>
+            </a:r>
+            <a:endParaRPr/>
+          </a:p>
+          <a:p>
+            <a:pPr indent="0" lvl="0" marL="0" rtl="0" algn="l">
+              <a:spcBef>
+                <a:spcPts val="0"/>
+              </a:spcBef>
+              <a:spcAft>
+                <a:spcPts val="0"/>
+              </a:spcAft>
+              <a:buNone/>
+            </a:pPr>
+            <a:r>
+              <a:rPr lang="en-US"/>
+              <a:t/>
+            </a:r>
+            <a:endParaRPr/>
+          </a:p>
+          <a:p>
+            <a:pPr indent="0" lvl="0" marL="0" rtl="0" algn="l">
+              <a:spcBef>
+                <a:spcPts val="0"/>
+              </a:spcBef>
+              <a:spcAft>
+                <a:spcPts val="0"/>
+              </a:spcAft>
+              <a:buNone/>
+            </a:pPr>
+            <a:r>
+              <a:t/>
+            </a:r>
+            <a:endParaRPr/>
+          </a:p>
+          <a:p>
+            <a:pPr indent="0" lvl="0" marL="0" rtl="0" algn="l">
+              <a:spcBef>
+                <a:spcPts val="0"/>
+              </a:spcBef>
+              <a:spcAft>
+                <a:spcPts val="0"/>
+              </a:spcAft>
+              <a:buNone/>
+            </a:pPr>
+            <a:r>
+              <a:rPr lang="en-US"/>
+              <a:t/>
+            </a:r>
+            <a:endParaRPr/>
+          </a:p>
+          <a:p>
+            <a:pPr indent="0" lvl="0" marL="0" rtl="0" algn="l">
+              <a:spcBef>
+                <a:spcPts val="0"/>
+              </a:spcBef>
+              <a:spcAft>
+                <a:spcPts val="0"/>
+              </a:spcAft>
+              <a:buNone/>
+            </a:pPr>
+            <a:r>
+              <a:t/>
+            </a:r>
+            <a:endParaRPr/>
+          </a:p>
+          <a:p>
+            <a:pPr indent="0" lvl="0" marL="0" rtl="0" algn="l">
+              <a:spcBef>
+                <a:spcPts val="0"/>
+              </a:spcBef>
+              <a:spcAft>
+                <a:spcPts val="0"/>
+              </a:spcAft>
+              <a:buNone/>
+            </a:pPr>
+            <a:r>
+              <a:rPr lang="en-US"/>
+              <a:t/>
+            </a:r>
+            <a:endParaRPr/>
+          </a:p>
+          <a:p>
+            <a:pPr indent="0" lvl="0" marL="0" rtl="0" algn="l">
+              <a:spcBef>
+                <a:spcPts val="0"/>
+              </a:spcBef>
+              <a:spcAft>
+                <a:spcPts val="0"/>
+              </a:spcAft>
+              <a:buNone/>
+            </a:pPr>
+            <a:r>
+              <a:t/>
+            </a:r>
+            <a:endParaRPr/>
+          </a:p>
+          <a:p>
+            <a:pPr indent="0" lvl="0" marL="0" rtl="0" algn="l">
+              <a:spcBef>
+                <a:spcPts val="0"/>
+              </a:spcBef>
+              <a:spcAft>
+                <a:spcPts val="0"/>
+              </a:spcAft>
+              <a:buNone/>
+            </a:pPr>
+            <a:r>
+              <a:rPr lang="en-US"/>
+              <a:t/>
             </a:r>
             <a:endParaRPr/>
           </a:p>
@@ -12291,116 +12291,116 @@
             </a:pPr>
             <a:r>
               <a:rPr lang="en-US"/>
-              <a:t>S10 · 11/15 · actualización y protocolo.</a:t>
-            </a:r>
-            <a:endParaRPr/>
-          </a:p>
-          <a:p>
-            <a:pPr indent="0" lvl="0" marL="0" rtl="0" algn="l">
-              <a:spcBef>
-                <a:spcPts val="0"/>
-              </a:spcBef>
-              <a:spcAft>
-                <a:spcPts val="0"/>
-              </a:spcAft>
-              <a:buNone/>
-            </a:pPr>
-            <a:r>
-              <a:t/>
-            </a:r>
-            <a:endParaRPr/>
-          </a:p>
-          <a:p>
-            <a:pPr indent="0" lvl="0" marL="0" rtl="0" algn="l">
-              <a:spcBef>
-                <a:spcPts val="0"/>
-              </a:spcBef>
-              <a:spcAft>
-                <a:spcPts val="0"/>
-              </a:spcAft>
-              <a:buNone/>
-            </a:pPr>
-            <a:r>
-              <a:rPr lang="en-US"/>
-              <a:t>Abre corpus/fixtures/fragmento-sintetico.json. Léelo. No lo ingieras en el corpus del curso.</a:t>
-            </a:r>
-            <a:endParaRPr/>
-          </a:p>
-          <a:p>
-            <a:pPr indent="0" lvl="0" marL="0" rtl="0" algn="l">
-              <a:spcBef>
-                <a:spcPts val="0"/>
-              </a:spcBef>
-              <a:spcAft>
-                <a:spcPts val="0"/>
-              </a:spcAft>
-              <a:buNone/>
-            </a:pPr>
-            <a:r>
-              <a:t/>
-            </a:r>
-            <a:endParaRPr/>
-          </a:p>
-          <a:p>
-            <a:pPr indent="0" lvl="0" marL="0" rtl="0" algn="l">
-              <a:spcBef>
-                <a:spcPts val="0"/>
-              </a:spcBef>
-              <a:spcAft>
-                <a:spcPts val="0"/>
-              </a:spcAft>
-              <a:buNone/>
-            </a:pPr>
-            <a:r>
-              <a:rPr lang="en-US"/>
-              <a:t>Di: está marcado como sintético y no describe sesiones ni profesores.</a:t>
-            </a:r>
-            <a:endParaRPr/>
-          </a:p>
-          <a:p>
-            <a:pPr indent="0" lvl="0" marL="0" rtl="0" algn="l">
-              <a:spcBef>
-                <a:spcPts val="0"/>
-              </a:spcBef>
-              <a:spcAft>
-                <a:spcPts val="0"/>
-              </a:spcAft>
-              <a:buNone/>
-            </a:pPr>
-            <a:r>
-              <a:t/>
-            </a:r>
-            <a:endParaRPr/>
-          </a:p>
-          <a:p>
-            <a:pPr indent="0" lvl="0" marL="0" rtl="0" algn="l">
-              <a:spcBef>
-                <a:spcPts val="0"/>
-              </a:spcBef>
-              <a:spcAft>
-                <a:spcPts val="0"/>
-              </a:spcAft>
-              <a:buNone/>
-            </a:pPr>
-            <a:r>
-              <a:rPr lang="en-US"/>
-              <a:t>Reindexar de verdad exige recursos remotos que hoy no están autorizados.</a:t>
-            </a:r>
-            <a:endParaRPr/>
-          </a:p>
-          <a:p>
-            <a:pPr indent="0" lvl="0" marL="0" rtl="0" algn="l">
-              <a:spcBef>
-                <a:spcPts val="0"/>
-              </a:spcBef>
-              <a:spcAft>
-                <a:spcPts val="0"/>
-              </a:spcAft>
-              <a:buNone/>
-            </a:pPr>
-            <a:r>
-              <a:rPr lang="en-US"/>
-              <a:t>La comparación de 20 preguntas está preparada y no ejecutada.</a:t>
+              <a:t>S10 · 05/15 · bloque 10–25 min. Decisiones de fragmentación y solapamiento en packages/rag/src/chunk.ts y lab/src/corpus.ts. Se limpia el texto, se divide primero por secciones Markdown (##) y luego por párrafos hasta 900 caracteres con 80 de solapamiento. Explica por qué el solapamiento evita cortar una condición o cifra entre dos fragmentos y cómo se preserva la sección en el ID estable version:documento:ordinal.</a:t>
+            </a:r>
+            <a:endParaRPr/>
+          </a:p>
+          <a:p>
+            <a:pPr indent="0" lvl="0" marL="0" rtl="0" algn="l">
+              <a:spcBef>
+                <a:spcPts val="0"/>
+              </a:spcBef>
+              <a:spcAft>
+                <a:spcPts val="0"/>
+              </a:spcAft>
+              <a:buNone/>
+            </a:pPr>
+            <a:r>
+              <a:t/>
+            </a:r>
+            <a:endParaRPr/>
+          </a:p>
+          <a:p>
+            <a:pPr indent="0" lvl="0" marL="0" rtl="0" algn="l">
+              <a:spcBef>
+                <a:spcPts val="0"/>
+              </a:spcBef>
+              <a:spcAft>
+                <a:spcPts val="0"/>
+              </a:spcAft>
+              <a:buNone/>
+            </a:pPr>
+            <a:r>
+              <a:rPr lang="en-US"/>
+              <a:t/>
+            </a:r>
+            <a:endParaRPr/>
+          </a:p>
+          <a:p>
+            <a:pPr indent="0" lvl="0" marL="0" rtl="0" algn="l">
+              <a:spcBef>
+                <a:spcPts val="0"/>
+              </a:spcBef>
+              <a:spcAft>
+                <a:spcPts val="0"/>
+              </a:spcAft>
+              <a:buNone/>
+            </a:pPr>
+            <a:r>
+              <a:t/>
+            </a:r>
+            <a:endParaRPr/>
+          </a:p>
+          <a:p>
+            <a:pPr indent="0" lvl="0" marL="0" rtl="0" algn="l">
+              <a:spcBef>
+                <a:spcPts val="0"/>
+              </a:spcBef>
+              <a:spcAft>
+                <a:spcPts val="0"/>
+              </a:spcAft>
+              <a:buNone/>
+            </a:pPr>
+            <a:r>
+              <a:rPr lang="en-US"/>
+              <a:t/>
+            </a:r>
+            <a:endParaRPr/>
+          </a:p>
+          <a:p>
+            <a:pPr indent="0" lvl="0" marL="0" rtl="0" algn="l">
+              <a:spcBef>
+                <a:spcPts val="0"/>
+              </a:spcBef>
+              <a:spcAft>
+                <a:spcPts val="0"/>
+              </a:spcAft>
+              <a:buNone/>
+            </a:pPr>
+            <a:r>
+              <a:t/>
+            </a:r>
+            <a:endParaRPr/>
+          </a:p>
+          <a:p>
+            <a:pPr indent="0" lvl="0" marL="0" rtl="0" algn="l">
+              <a:spcBef>
+                <a:spcPts val="0"/>
+              </a:spcBef>
+              <a:spcAft>
+                <a:spcPts val="0"/>
+              </a:spcAft>
+              <a:buNone/>
+            </a:pPr>
+            <a:r>
+              <a:rPr lang="en-US"/>
+              <a:t/>
+            </a:r>
+            <a:endParaRPr/>
+          </a:p>
+          <a:p>
+            <a:pPr indent="0" lvl="0" marL="0" rtl="0" algn="l">
+              <a:spcBef>
+                <a:spcPts val="0"/>
+              </a:spcBef>
+              <a:spcAft>
+                <a:spcPts val="0"/>
+              </a:spcAft>
+              <a:buNone/>
+            </a:pPr>
+            <a:r>
+              <a:rPr lang="en-US"/>
+              <a:t/>
             </a:r>
             <a:endParaRPr/>
           </a:p>
@@ -22952,7 +22952,7 @@
                 <a:cs typeface="Inter"/>
                 <a:sym typeface="Inter"/>
               </a:rPr>
-              <a:t>Sin documentos y una sola búsqueda.</a:t>
+              <a:t>Recorrido semántico, umbral previo y citas verificables.</a:t>
             </a:r>
             <a:endParaRPr sz="1800">
               <a:solidFill>
@@ -22987,7 +22987,7 @@
                 <a:cs typeface="Inter"/>
                 <a:sym typeface="Inter"/>
               </a:rPr>
-              <a:t>La aplicación ya está construida.</a:t>
+              <a:t>Demostrador del curso y laboratorio pgvector reproducible.</a:t>
             </a:r>
             <a:endParaRPr sz="1800">
               <a:solidFill>
@@ -23287,7 +23287,7 @@
                 <a:cs typeface="Inter"/>
                 <a:sym typeface="Inter"/>
               </a:rPr>
-              <a:t>Demo local · TypeScript · Fixture</a:t>
+              <a:t>Semántico · BGE-M3 1024 / pgvector 768</a:t>
             </a:r>
             <a:endParaRPr sz="1600">
               <a:solidFill>
@@ -24918,7 +24918,7 @@
                 <a:cs typeface="Inter"/>
                 <a:sym typeface="Inter"/>
               </a:rPr>
-              <a:t>Mirar la recuperación antes</a:t>
+              <a:t>Calibración del umbral y rechazo</a:t>
             </a:r>
             <a:endParaRPr b="1" sz="2800">
               <a:solidFill>
@@ -24979,7 +24979,7 @@
                 <a:cs typeface="Inter"/>
                 <a:sym typeface="Inter"/>
               </a:rPr>
-              <a:t>La traza enseña consulta, puntuación y decisión.</a:t>
+              <a:t>Se calibra con validación separada del test; corta antes de generar.</a:t>
             </a:r>
             <a:endParaRPr>
               <a:solidFill>
@@ -25371,7 +25371,7 @@
                 <a:cs typeface="Fira Code"/>
                 <a:sym typeface="Fira Code"/>
               </a:rPr>
-              <a:t>bun run dev</a:t>
+              <a:t>sim &gt;= 0.50 // BGE-M3 1024d</a:t>
             </a:r>
             <a:endParaRPr sz="1350">
               <a:solidFill>
@@ -25406,7 +25406,7 @@
                 <a:cs typeface="Fira Code"/>
                 <a:sym typeface="Fira Code"/>
               </a:rPr>
-              <a:t>http://localhost:5173/</a:t>
+              <a:t>dist &lt;= 0.75 // pgvector 768d</a:t>
             </a:r>
             <a:endParaRPr sz="1350">
               <a:solidFill>
@@ -25467,7 +25467,7 @@
                 <a:cs typeface="Inter"/>
                 <a:sym typeface="Inter"/>
               </a:rPr>
-              <a:t>Consulta</a:t>
+              <a:t>Validación</a:t>
             </a:r>
             <a:endParaRPr b="1" sz="1800">
               <a:solidFill>
@@ -25528,7 +25528,7 @@
                 <a:cs typeface="Inter"/>
                 <a:sym typeface="Inter"/>
               </a:rPr>
-              <a:t>Puntuación</a:t>
+              <a:t>Umbral</a:t>
             </a:r>
             <a:endParaRPr b="1" sz="1800">
               <a:solidFill>
@@ -25589,7 +25589,7 @@
                 <a:cs typeface="Inter"/>
                 <a:sym typeface="Inter"/>
               </a:rPr>
-              <a:t>Decisión</a:t>
+              <a:t>Rechazo</a:t>
             </a:r>
             <a:endParaRPr b="1" sz="1800">
               <a:solidFill>
@@ -25650,7 +25650,7 @@
                 <a:cs typeface="Inter"/>
                 <a:sym typeface="Inter"/>
               </a:rPr>
-              <a:t>Generar solo si hay contexto utilizable.</a:t>
+              <a:t>Un prompt de «si no sabes, dilo» no sustituye este control.</a:t>
             </a:r>
             <a:endParaRPr sz="1500">
               <a:solidFill>
@@ -25932,7 +25932,7 @@
                 <a:cs typeface="Inter"/>
                 <a:sym typeface="Inter"/>
               </a:rPr>
-              <a:t>Ejercicio y el paso a CRAG</a:t>
+              <a:t>Ejercicio S10 y el paso a CRAG</a:t>
             </a:r>
             <a:endParaRPr b="1" sz="2800">
               <a:solidFill>
@@ -25993,7 +25993,7 @@
                 <a:cs typeface="Inter"/>
                 <a:sym typeface="Inter"/>
               </a:rPr>
-              <a:t>La práctica local no exige pagar un alojamiento.</a:t>
+              <a:t>8+ documentos ficticios y PostgreSQL con pgvector (vector(768) + HNSW).</a:t>
             </a:r>
             <a:endParaRPr>
               <a:solidFill>
@@ -26108,7 +26108,7 @@
                 <a:cs typeface="Inter"/>
                 <a:sym typeface="Inter"/>
               </a:rPr>
-              <a:t>Qué entregar</a:t>
+              <a:t>Stack e índice</a:t>
             </a:r>
             <a:endParaRPr b="1" sz="1800">
               <a:solidFill>
@@ -26169,7 +26169,7 @@
                 <a:cs typeface="Inter"/>
                 <a:sym typeface="Inter"/>
               </a:rPr>
-              <a:t>Corpus, una búsqueda, cita y rechazo.</a:t>
+              <a:t>GEN_MODEL_ID, EMBEDDING_MODEL_ID, vector(768) e índice HNSW.</a:t>
             </a:r>
             <a:endParaRPr sz="1550">
               <a:solidFill>
@@ -26257,7 +26257,7 @@
                 <a:cs typeface="Inter"/>
                 <a:sym typeface="Inter"/>
               </a:rPr>
-              <a:t>Qué no pedir</a:t>
+              <a:t>Reconstrucción</a:t>
             </a:r>
             <a:endParaRPr b="1" sz="1800">
               <a:solidFill>
@@ -26318,7 +26318,7 @@
                 <a:cs typeface="Inter"/>
                 <a:sym typeface="Inter"/>
               </a:rPr>
-              <a:t>Ni despliegue ni una cuenta de pago.</a:t>
+              <a:t>Desde archivos en bruto e índice vacío, con umbral y citas.</a:t>
             </a:r>
             <a:endParaRPr sz="1550">
               <a:solidFill>
@@ -26406,7 +26406,7 @@
                 <a:cs typeface="Inter"/>
                 <a:sym typeface="Inter"/>
               </a:rPr>
-              <a:t>Después</a:t>
+              <a:t>Evaluación 14+6</a:t>
             </a:r>
             <a:endParaRPr b="1" sz="1800">
               <a:solidFill>
@@ -26467,7 +26467,7 @@
                 <a:cs typeface="Inter"/>
                 <a:sym typeface="Inter"/>
               </a:rPr>
-              <a:t>El 27 de octubre el mismo asistente pasa a CRAG.</a:t>
+              <a:t>Ejecutar las 20 preguntas y presentar aciertos/14 y rechazos/6.</a:t>
             </a:r>
             <a:endParaRPr sz="1550">
               <a:solidFill>
@@ -26637,7 +26637,7 @@
                 <a:cs typeface="Inter"/>
                 <a:sym typeface="Inter"/>
               </a:rPr>
-              <a:t>Orientativo del encargo original: 4 a 6 horas.</a:t>
+              <a:t>Dedicación orientativa: 4 a 6 horas. Laboratorio en lab/.</a:t>
             </a:r>
             <a:endParaRPr sz="1350">
               <a:solidFill>
@@ -26838,7 +26838,7 @@
                 <a:cs typeface="Inter"/>
                 <a:sym typeface="Inter"/>
               </a:rPr>
-              <a:t>Consulta · Demo y perfil real</a:t>
+              <a:t>Consulta · Los tres perfiles del proyecto</a:t>
             </a:r>
             <a:endParaRPr b="1" sz="2800">
               <a:solidFill>
@@ -26899,7 +26899,7 @@
                 <a:cs typeface="Inter"/>
                 <a:sym typeface="Inter"/>
               </a:rPr>
-              <a:t>La demo de hoy está verificada en local. Lo remoto sigue pendiente.</a:t>
+              <a:t>Recorrido semántico principal, laboratorio pgvector y respaldo demo.</a:t>
             </a:r>
             <a:endParaRPr>
               <a:solidFill>
@@ -27058,7 +27058,7 @@
                           <a:cs typeface="Inter"/>
                           <a:sym typeface="Inter"/>
                         </a:rPr>
-                        <a:t>Demo de clase</a:t>
+                        <a:t>Curso (semántico)</a:t>
                       </a:r>
                       <a:endParaRPr b="1" sz="1500">
                         <a:solidFill>
@@ -27101,7 +27101,7 @@
                           <a:cs typeface="Inter"/>
                           <a:sym typeface="Inter"/>
                         </a:rPr>
-                        <a:t>Perfil real</a:t>
+                        <a:t>Laboratorio (S10/S11)</a:t>
                       </a:r>
                       <a:endParaRPr b="1" sz="1500">
                         <a:solidFill>
@@ -27189,7 +27189,7 @@
                           <a:cs typeface="Inter"/>
                           <a:sym typeface="Inter"/>
                         </a:rPr>
-                        <a:t>Hash lexical, 128 d</a:t>
+                        <a:t>Vectorize 1024 d (BGE-M3)</a:t>
                       </a:r>
                       <a:endParaRPr sz="1500">
                         <a:solidFill>
@@ -27232,7 +27232,7 @@
                           <a:cs typeface="Inter"/>
                           <a:sym typeface="Inter"/>
                         </a:rPr>
-                        <a:t>Vectorize, dimensión pendiente</a:t>
+                        <a:t>pgvector vector(768) + HNSW</a:t>
                       </a:r>
                       <a:endParaRPr sz="1500">
                         <a:solidFill>
@@ -27277,7 +27277,7 @@
                           <a:cs typeface="Inter"/>
                           <a:sym typeface="Inter"/>
                         </a:rPr>
-                        <a:t>Generación</a:t>
+                        <a:t>Modelo</a:t>
                       </a:r>
                       <a:endParaRPr sz="1500">
                         <a:solidFill>
@@ -27320,7 +27320,7 @@
                           <a:cs typeface="Inter"/>
                           <a:sym typeface="Inter"/>
                         </a:rPr>
-                        <a:t>Stream sin modelo</a:t>
+                        <a:t>claude-haiku-5-5 (Anthropic)</a:t>
                       </a:r>
                       <a:endParaRPr sz="1500">
                         <a:solidFill>
@@ -27363,7 +27363,7 @@
                           <a:cs typeface="Inter"/>
                           <a:sym typeface="Inter"/>
                         </a:rPr>
-                        <a:t>OpenRouter, modelo pendiente</a:t>
+                        <a:t>GEN_MODEL_ID / EMBEDDING_MODEL_ID</a:t>
                       </a:r>
                       <a:endParaRPr sz="1500">
                         <a:solidFill>
@@ -27451,7 +27451,7 @@
                           <a:cs typeface="Inter"/>
                           <a:sym typeface="Inter"/>
                         </a:rPr>
-                        <a:t>0,33 solo de esta demo</a:t>
+                        <a:t>0,50 (variante: complete)</a:t>
                       </a:r>
                       <a:endParaRPr sz="1500">
                         <a:solidFill>
@@ -27494,7 +27494,7 @@
                           <a:cs typeface="Inter"/>
                           <a:sym typeface="Inter"/>
                         </a:rPr>
-                        <a:t>Calibrado; no copiar 0,33</a:t>
+                        <a:t>0,25 similitud (0,75 distancia &lt;=&gt;)</a:t>
                       </a:r>
                       <a:endParaRPr sz="1500">
                         <a:solidFill>
@@ -27565,7 +27565,7 @@
                 <a:cs typeface="Inter"/>
                 <a:sym typeface="Inter"/>
               </a:rPr>
-              <a:t>Un tope de gasto no demuestra solo el camino real.</a:t>
+              <a:t>En demo offline se usa fixture-token-hash-v1 (128 d, corte 0,33).</a:t>
             </a:r>
             <a:endParaRPr sz="1350">
               <a:solidFill>
@@ -30285,7 +30285,7 @@
                 <a:cs typeface="Inter"/>
                 <a:sym typeface="Inter"/>
               </a:rPr>
-              <a:t>Sin RAG, el corpus, una búsqueda y las citas.</a:t>
+              <a:t>Fragmentación, embeddings, índice HNSW, umbral y citas.</a:t>
             </a:r>
             <a:endParaRPr sz="1700">
               <a:solidFill>
@@ -31098,7 +31098,7 @@
                 <a:cs typeface="Inter"/>
                 <a:sym typeface="Inter"/>
               </a:rPr>
-              <a:t>En demo es un stream local, no un modelo.</a:t>
+              <a:t>El modelo responde sin fuentes y desconoce fechas internas.</a:t>
             </a:r>
             <a:endParaRPr sz="1550">
               <a:solidFill>
@@ -31247,7 +31247,7 @@
                 <a:cs typeface="Inter"/>
                 <a:sym typeface="Inter"/>
               </a:rPr>
-              <a:t>Uso y coste figuran como no medidos.</a:t>
+              <a:t>Sin citas; uso o coste desconocidos viajan como null.</a:t>
             </a:r>
             <a:endParaRPr sz="1550">
               <a:solidFill>
@@ -31584,7 +31584,7 @@
                 <a:cs typeface="Inter"/>
                 <a:sym typeface="Inter"/>
               </a:rPr>
-              <a:t>Fragmento, id y vector</a:t>
+              <a:t>Embeddings e índice vectorial</a:t>
             </a:r>
             <a:endParaRPr b="1" sz="2800">
               <a:solidFill>
@@ -31645,7 +31645,7 @@
                 <a:cs typeface="Inter"/>
                 <a:sym typeface="Inter"/>
               </a:rPr>
-              <a:t>El id es la cita. El vector de demo no es BGE-M3.</a:t>
+              <a:t>Mismo modelo y dimensión al ingerir documentos y al consultar.</a:t>
             </a:r>
             <a:endParaRPr>
               <a:solidFill>
@@ -32037,7 +32037,7 @@
                 <a:cs typeface="Fira Code"/>
                 <a:sym typeface="Fira Code"/>
               </a:rPr>
-              <a:t>function chunkId(v, doc, n) {</a:t>
+              <a:t>embedding vector(768) NOT NULL</a:t>
             </a:r>
             <a:endParaRPr sz="1350">
               <a:solidFill>
@@ -32072,7 +32072,7 @@
                 <a:cs typeface="Fira Code"/>
                 <a:sym typeface="Fira Code"/>
               </a:rPr>
-              <a:t xml:space="preserve">  const o = String(n).padStart(2, "0")</a:t>
+              <a:t xml:space="preserve">USING hnsw (embedding</a:t>
             </a:r>
             <a:endParaRPr sz="1350">
               <a:solidFill>
@@ -32098,7 +32098,16 @@
               <a:buNone/>
             </a:pPr>
             <a:r>
-              <a:t/>
+              <a:rPr lang="en-US" sz="1350">
+                <a:solidFill>
+                  <a:srgbClr val="32C5F4"/>
+                </a:solidFill>
+                <a:latin typeface="Fira Code"/>
+                <a:ea typeface="Fira Code"/>
+                <a:cs typeface="Fira Code"/>
+                <a:sym typeface="Fira Code"/>
+              </a:rPr>
+              <a:t>  vector_cosine_ops)</a:t>
             </a:r>
             <a:endParaRPr sz="1350">
               <a:solidFill>
@@ -32133,7 +32142,7 @@
                 <a:cs typeface="Fira Code"/>
                 <a:sym typeface="Fira Code"/>
               </a:rPr>
-              <a:t xml:space="preserve">  return `${v}:${doc}:${o}`</a:t>
+              <a:t xml:space="preserve">WITH (m = 16, ef_construction = 64)</a:t>
             </a:r>
             <a:endParaRPr sz="1350">
               <a:solidFill>
@@ -32168,7 +32177,7 @@
                 <a:cs typeface="Fira Code"/>
                 <a:sym typeface="Fira Code"/>
               </a:rPr>
-              <a:t>}</a:t>
+              <a:t/>
             </a:r>
             <a:endParaRPr sz="1350">
               <a:solidFill>
@@ -32203,7 +32212,7 @@
                 <a:cs typeface="Fira Code"/>
                 <a:sym typeface="Fira Code"/>
               </a:rPr>
-              <a:t>vectorIdFor(id) // cabe en 64 bytes</a:t>
+              <a:t/>
             </a:r>
             <a:endParaRPr sz="1350">
               <a:solidFill>
@@ -32264,7 +32273,7 @@
                 <a:cs typeface="Inter"/>
                 <a:sym typeface="Inter"/>
               </a:rPr>
-              <a:t>Texto</a:t>
+              <a:t>Fragmento</a:t>
             </a:r>
             <a:endParaRPr b="1" sz="1800">
               <a:solidFill>
@@ -32325,7 +32334,7 @@
                 <a:cs typeface="Inter"/>
                 <a:sym typeface="Inter"/>
               </a:rPr>
-              <a:t>Identificador</a:t>
+              <a:t>Vector 768/1024</a:t>
             </a:r>
             <a:endParaRPr b="1" sz="1800">
               <a:solidFill>
@@ -32386,7 +32395,7 @@
                 <a:cs typeface="Inter"/>
                 <a:sym typeface="Inter"/>
               </a:rPr>
-              <a:t>Vector</a:t>
+              <a:t>Índice HNSW</a:t>
             </a:r>
             <a:endParaRPr b="1" sz="1800">
               <a:solidFill>
@@ -32447,7 +32456,7 @@
                 <a:cs typeface="Inter"/>
                 <a:sym typeface="Inter"/>
               </a:rPr>
-              <a:t>fixture-token-hash-v1 · 128 · coseno</a:t>
+              <a:t>Lab: vector(768) + HNSW · Curso: BGE-M3 1024 d</a:t>
             </a:r>
             <a:endParaRPr sz="1500">
               <a:solidFill>
@@ -32508,7 +32517,7 @@
                 <a:cs typeface="Fira Code"/>
                 <a:sym typeface="Fira Code"/>
               </a:rPr>
-              <a:t>Umbral lexical de la demo: 0,33</a:t>
+              <a:t>En pgvector &lt;=&gt;, menor distancia = más próximo</a:t>
             </a:r>
             <a:endParaRPr sz="1300">
               <a:solidFill>
@@ -32790,7 +32799,7 @@
                 <a:cs typeface="Inter"/>
                 <a:sym typeface="Inter"/>
               </a:rPr>
-              <a:t>Contexto, respuesta y cita</a:t>
+              <a:t>Construcción del contexto y citas</a:t>
             </a:r>
             <a:endParaRPr b="1" sz="2800">
               <a:solidFill>
@@ -32851,7 +32860,7 @@
                 <a:cs typeface="Inter"/>
                 <a:sym typeface="Inter"/>
               </a:rPr>
-              <a:t>La cita usa el id del fragmento. Se puede abrir.</a:t>
+              <a:t>El texto recuperado es dato no fiable, nunca instrucción.</a:t>
             </a:r>
             <a:endParaRPr>
               <a:solidFill>
@@ -32966,7 +32975,7 @@
                 <a:cs typeface="Inter"/>
                 <a:sym typeface="Inter"/>
               </a:rPr>
-              <a:t>Contexto</a:t>
+              <a:t>Bloque DATOS</a:t>
             </a:r>
             <a:endParaRPr b="1" sz="1800">
               <a:solidFill>
@@ -33027,7 +33036,7 @@
                 <a:cs typeface="Inter"/>
                 <a:sym typeface="Inter"/>
               </a:rPr>
-              <a:t>Solo entran los fragmentos seleccionados.</a:t>
+              <a:t>Aísla los fragmentos frente a instrucciones incrustadas.</a:t>
             </a:r>
             <a:endParaRPr sz="1550">
               <a:solidFill>
@@ -33115,7 +33124,7 @@
                 <a:cs typeface="Inter"/>
                 <a:sym typeface="Inter"/>
               </a:rPr>
-              <a:t>Respuesta</a:t>
+              <a:t>Generación</a:t>
             </a:r>
             <a:endParaRPr b="1" sz="1800">
               <a:solidFill>
@@ -33176,7 +33185,7 @@
                 <a:cs typeface="Inter"/>
                 <a:sym typeface="Inter"/>
               </a:rPr>
-              <a:t>En demo no llama a un modelo de pago.</a:t>
+              <a:t>Redacta solo con los fragmentos que superaron el corte.</a:t>
             </a:r>
             <a:endParaRPr sz="1550">
               <a:solidFill>
@@ -33264,7 +33273,7 @@
                 <a:cs typeface="Inter"/>
                 <a:sym typeface="Inter"/>
               </a:rPr>
-              <a:t>Cita</a:t>
+              <a:t>Cita [cite:id]</a:t>
             </a:r>
             <a:endParaRPr b="1" sz="1800">
               <a:solidFill>
@@ -33325,7 +33334,7 @@
                 <a:cs typeface="Inter"/>
                 <a:sym typeface="Inter"/>
               </a:rPr>
-              <a:t>Formato [cite:id], resoluble en el corpus.</a:t>
+              <a:t>Se valida contra los IDs seleccionados antes de responder.</a:t>
             </a:r>
             <a:endParaRPr sz="1550">
               <a:solidFill>
@@ -33495,7 +33504,7 @@
                 <a:cs typeface="Fira Code"/>
                 <a:sym typeface="Fira Code"/>
               </a:rPr>
-              <a:t>Etapa RAG básico. Una sola búsqueda.</a:t>
+              <a:t>Variante complete: solo cuando todo el corpus cabe en ventana.</a:t>
             </a:r>
             <a:endParaRPr>
               <a:solidFill>
@@ -33696,7 +33705,7 @@
                 <a:cs typeface="Inter"/>
                 <a:sym typeface="Inter"/>
               </a:rPr>
-              <a:t>Recuperar, filtrar y puntuar</a:t>
+              <a:t>Consultar, filtrar y puntuar</a:t>
             </a:r>
             <a:endParaRPr b="1" sz="2800">
               <a:solidFill>
@@ -33757,7 +33766,7 @@
                 <a:cs typeface="Inter"/>
                 <a:sym typeface="Inter"/>
               </a:rPr>
-              <a:t>La puntuación ordena candidatos. No es una probabilidad.</a:t>
+              <a:t>Filtro en la consulta vectorial y selección por umbral previo.</a:t>
             </a:r>
             <a:endParaRPr>
               <a:solidFill>
@@ -33990,7 +33999,7 @@
                 <a:cs typeface="Inter"/>
                 <a:sym typeface="Inter"/>
               </a:rPr>
-              <a:t>Pregunta</a:t>
+              <a:t>Embebe</a:t>
             </a:r>
             <a:endParaRPr b="1" sz="1700">
               <a:solidFill>
@@ -34194,7 +34203,7 @@
                 <a:cs typeface="Inter"/>
                 <a:sym typeface="Inter"/>
               </a:rPr>
-              <a:t>Audiencia</a:t>
+              <a:t>Filtra</a:t>
             </a:r>
             <a:endParaRPr b="1" sz="1700">
               <a:solidFill>
@@ -34398,7 +34407,7 @@
                 <a:cs typeface="Inter"/>
                 <a:sym typeface="Inter"/>
               </a:rPr>
-              <a:t>Coseno</a:t>
+              <a:t>Distancia</a:t>
             </a:r>
             <a:endParaRPr b="1" sz="1700">
               <a:solidFill>
@@ -34806,7 +34815,7 @@
                 <a:cs typeface="Inter"/>
                 <a:sym typeface="Inter"/>
               </a:rPr>
-              <a:t>Candidatos</a:t>
+              <a:t>Contexto</a:t>
             </a:r>
             <a:endParaRPr b="1" sz="1700">
               <a:solidFill>
@@ -34867,7 +34876,7 @@
                 <a:cs typeface="Inter"/>
                 <a:sym typeface="Inter"/>
               </a:rPr>
-              <a:t>General no mezcla el calendario L/X con el M/J.</a:t>
+              <a:t>El filtro de grupo se aplica en la consulta, no solo en el prompt.</a:t>
             </a:r>
             <a:endParaRPr sz="1800">
               <a:solidFill>
@@ -35068,7 +35077,7 @@
                 <a:cs typeface="Inter"/>
                 <a:sym typeface="Inter"/>
               </a:rPr>
-              <a:t>Corpus de todo el programa</a:t>
+              <a:t>Corpus y perfiles del sistema</a:t>
             </a:r>
             <a:endParaRPr b="1" sz="2800">
               <a:solidFill>
@@ -35129,7 +35138,7 @@
                 <a:cs typeface="Inter"/>
                 <a:sym typeface="Inter"/>
               </a:rPr>
-              <a:t>S1 a S20 y dos calendarios. No es una empresa de ficción.</a:t>
+              <a:t>S1–S20 en el demostrador y 10 documentos ficticios en lab/.</a:t>
             </a:r>
             <a:endParaRPr>
               <a:solidFill>
@@ -35331,7 +35340,7 @@
                           <a:cs typeface="Inter"/>
                           <a:sym typeface="Inter"/>
                         </a:rPr>
-                        <a:t>Estado</a:t>
+                        <a:t>Estado verificado</a:t>
                       </a:r>
                       <a:endParaRPr b="1" sz="1500">
                         <a:solidFill>
@@ -35376,7 +35385,7 @@
                           <a:cs typeface="Inter"/>
                           <a:sym typeface="Inter"/>
                         </a:rPr>
-                        <a:t>Preparación</a:t>
+                        <a:t>Corpus curso</a:t>
                       </a:r>
                       <a:endParaRPr sz="1500">
                         <a:solidFill>
@@ -35462,7 +35471,7 @@
                           <a:cs typeface="Inter"/>
                           <a:sym typeface="Inter"/>
                         </a:rPr>
-                        <a:t>Congelada</a:t>
+                        <a:t>22 docs, 69 fragmentos</a:t>
                       </a:r>
                       <a:endParaRPr sz="1500">
                         <a:solidFill>
@@ -35507,7 +35516,7 @@
                           <a:cs typeface="Inter"/>
                           <a:sym typeface="Inter"/>
                         </a:rPr>
-                        <a:t>Contenido</a:t>
+                        <a:t>Índice real</a:t>
                       </a:r>
                       <a:endParaRPr sz="1500">
                         <a:solidFill>
@@ -35550,7 +35559,7 @@
                           <a:cs typeface="Inter"/>
                           <a:sym typeface="Inter"/>
                         </a:rPr>
-                        <a:t>cc037ef0bb1f7</a:t>
+                        <a:t>p76509a5f9743</a:t>
                       </a:r>
                       <a:endParaRPr sz="1500">
                         <a:solidFill>
@@ -35593,7 +35602,7 @@
                           <a:cs typeface="Inter"/>
                           <a:sym typeface="Inter"/>
                         </a:rPr>
-                        <a:t>Congelado</a:t>
+                        <a:t>BGE-M3 1024 d, coseno 0,50</a:t>
                       </a:r>
                       <a:endParaRPr sz="1500">
                         <a:solidFill>
@@ -35638,7 +35647,7 @@
                           <a:cs typeface="Inter"/>
                           <a:sym typeface="Inter"/>
                         </a:rPr>
-                        <a:t>Perfil demo</a:t>
+                        <a:t>Lab pgvector</a:t>
                       </a:r>
                       <a:endParaRPr sz="1500">
                         <a:solidFill>
@@ -35681,7 +35690,7 @@
                           <a:cs typeface="Inter"/>
                           <a:sym typeface="Inter"/>
                         </a:rPr>
-                        <a:t>p9e8e8e03627e</a:t>
+                        <a:t>lab-689164ca81cd</a:t>
                       </a:r>
                       <a:endParaRPr sz="1500">
                         <a:solidFill>
@@ -35724,7 +35733,7 @@
                           <a:cs typeface="Inter"/>
                           <a:sym typeface="Inter"/>
                         </a:rPr>
-                        <a:t>Fixture, no remoto</a:t>
+                        <a:t>10 docs, vector(768) + HNSW</a:t>
                       </a:r>
                       <a:endParaRPr sz="1500">
                         <a:solidFill>
@@ -35795,7 +35804,7 @@
                 <a:cs typeface="Inter"/>
                 <a:sym typeface="Inter"/>
               </a:rPr>
-              <a:t>Ocho ejercicios siguen solo con el título.</a:t>
+              <a:t>Ambos reconstruibles desde Markdown en bruto e índice vacío.</a:t>
             </a:r>
             <a:endParaRPr sz="1350">
               <a:solidFill>
@@ -35996,7 +36005,7 @@
                 <a:cs typeface="Inter"/>
                 <a:sym typeface="Inter"/>
               </a:rPr>
-              <a:t>Preparar no es preguntar</a:t>
+              <a:t>Fragmentación y solapamiento</a:t>
             </a:r>
             <a:endParaRPr b="1" sz="2800">
               <a:solidFill>
@@ -36057,7 +36066,7 @@
                 <a:cs typeface="Inter"/>
                 <a:sym typeface="Inter"/>
               </a:rPr>
-              <a:t>La preparación deja el corpus listo. La pregunta solo consulta.</a:t>
+              <a:t>Trocear por secciones y párrafos sin cortar un dato a mitad.</a:t>
             </a:r>
             <a:endParaRPr>
               <a:solidFill>
@@ -36285,7 +36294,7 @@
                 <a:cs typeface="Inter"/>
                 <a:sym typeface="Inter"/>
               </a:rPr>
-              <a:t>Preparación</a:t>
+              <a:t>Tamaño y solape</a:t>
             </a:r>
             <a:endParaRPr b="1" sz="2100">
               <a:solidFill>
@@ -36346,7 +36355,7 @@
                 <a:cs typeface="Inter"/>
                 <a:sym typeface="Inter"/>
               </a:rPr>
-              <a:t>Fragmentos, hash e identidad. No se repite en cada pregunta.</a:t>
+              <a:t>900 caracteres y 80 de solapamiento entre fragmentos.</a:t>
             </a:r>
             <a:endParaRPr sz="1600">
               <a:solidFill>
@@ -36407,7 +36416,7 @@
                 <a:cs typeface="Inter"/>
                 <a:sym typeface="Inter"/>
               </a:rPr>
-              <a:t>Consulta</a:t>
+              <a:t>Sección e ID</a:t>
             </a:r>
             <a:endParaRPr b="1" sz="2100">
               <a:solidFill>
@@ -36468,7 +36477,7 @@
                 <a:cs typeface="Inter"/>
                 <a:sym typeface="Inter"/>
               </a:rPr>
-              <a:t>Una búsqueda, filtro de audiencia y un umbral.</a:t>
+              <a:t>Conserva el encabezado H2 y crea un ID determinista.</a:t>
             </a:r>
             <a:endParaRPr sz="1600">
               <a:solidFill>
@@ -36585,7 +36594,7 @@
                 <a:cs typeface="Fira Code"/>
                 <a:sym typeface="Fira Code"/>
               </a:rPr>
-              <a:t>function chunkId(v, doc, n) {</a:t>
+              <a:t>chunkMarkdown(body, {</a:t>
             </a:r>
             <a:endParaRPr sz="1350">
               <a:solidFill>
@@ -36620,7 +36629,7 @@
                 <a:cs typeface="Fira Code"/>
                 <a:sym typeface="Fira Code"/>
               </a:rPr>
-              <a:t xml:space="preserve">  const o = String(n)</a:t>
+              <a:t xml:space="preserve">  maxChars: 900,</a:t>
             </a:r>
             <a:endParaRPr sz="1350">
               <a:solidFill>
@@ -36655,7 +36664,7 @@
                 <a:cs typeface="Fira Code"/>
                 <a:sym typeface="Fira Code"/>
               </a:rPr>
-              <a:t xml:space="preserve">    .padStart(2, "0")</a:t>
+              <a:t xml:space="preserve">  overlapChars: 80,</a:t>
             </a:r>
             <a:endParaRPr sz="1350">
               <a:solidFill>
@@ -36690,7 +36699,7 @@
                 <a:cs typeface="Fira Code"/>
                 <a:sym typeface="Fira Code"/>
               </a:rPr>
-              <a:t xml:space="preserve">  return `${v}:${doc}:${o}`</a:t>
+              <a:t xml:space="preserve">});</a:t>
             </a:r>
             <a:endParaRPr sz="1350">
               <a:solidFill>
@@ -36725,7 +36734,7 @@
                 <a:cs typeface="Fira Code"/>
                 <a:sym typeface="Fira Code"/>
               </a:rPr>
-              <a:t>}</a:t>
+              <a:t>// Conserva sección ##</a:t>
             </a:r>
             <a:endParaRPr sz="1350">
               <a:solidFill>
@@ -36760,7 +36769,7 @@
                 <a:cs typeface="Fira Code"/>
                 <a:sym typeface="Fira Code"/>
               </a:rPr>
-              <a:t>// c3a59a406888b:</a:t>
+              <a:t>// y solapa 80 chars</a:t>
             </a:r>
             <a:endParaRPr sz="1350">
               <a:solidFill>
@@ -36795,42 +36804,7 @@
                 <a:cs typeface="Fira Code"/>
                 <a:sym typeface="Fira Code"/>
               </a:rPr>
-              <a:t>// s05-langgraph:00</a:t>
-            </a:r>
-            <a:endParaRPr sz="1350">
-              <a:solidFill>
-                <a:srgbClr val="32C5F4"/>
-              </a:solidFill>
-              <a:latin typeface="Fira Code"/>
-              <a:ea typeface="Fira Code"/>
-              <a:cs typeface="Fira Code"/>
-              <a:sym typeface="Fira Code"/>
-            </a:endParaRPr>
-          </a:p>
-          <a:p>
-            <a:pPr indent="0" lvl="0" marL="0" rtl="0" algn="l">
-              <a:lnSpc>
-                <a:spcPct val="115000"/>
-              </a:lnSpc>
-              <a:spcBef>
-                <a:spcPts val="0"/>
-              </a:spcBef>
-              <a:spcAft>
-                <a:spcPts val="0"/>
-              </a:spcAft>
-              <a:buNone/>
-            </a:pPr>
-            <a:r>
-              <a:rPr lang="en-US" sz="1350">
-                <a:solidFill>
-                  <a:srgbClr val="32C5F4"/>
-                </a:solidFill>
-                <a:latin typeface="Fira Code"/>
-                <a:ea typeface="Fira Code"/>
-                <a:cs typeface="Fira Code"/>
-                <a:sym typeface="Fira Code"/>
-              </a:rPr>
-              <a:t>// Python: un f-string</a:t>
+              <a:t>// ID: version:doc:00</a:t>
             </a:r>
             <a:endParaRPr sz="1350">
               <a:solidFill>
@@ -36866,6 +36840,41 @@
                 <a:sym typeface="Fira Code"/>
               </a:rPr>
               <a:t>// packages/rag/src/chunk.ts</a:t>
+            </a:r>
+            <a:endParaRPr sz="1350">
+              <a:solidFill>
+                <a:srgbClr val="32C5F4"/>
+              </a:solidFill>
+              <a:latin typeface="Fira Code"/>
+              <a:ea typeface="Fira Code"/>
+              <a:cs typeface="Fira Code"/>
+              <a:sym typeface="Fira Code"/>
+            </a:endParaRPr>
+          </a:p>
+          <a:p>
+            <a:pPr indent="0" lvl="0" marL="0" rtl="0" algn="l">
+              <a:lnSpc>
+                <a:spcPct val="115000"/>
+              </a:lnSpc>
+              <a:spcBef>
+                <a:spcPts val="0"/>
+              </a:spcBef>
+              <a:spcAft>
+                <a:spcPts val="0"/>
+              </a:spcAft>
+              <a:buNone/>
+            </a:pPr>
+            <a:r>
+              <a:rPr lang="en-US" sz="1350">
+                <a:solidFill>
+                  <a:srgbClr val="32C5F4"/>
+                </a:solidFill>
+                <a:latin typeface="Fira Code"/>
+                <a:ea typeface="Fira Code"/>
+                <a:cs typeface="Fira Code"/>
+                <a:sym typeface="Fira Code"/>
+              </a:rPr>
+              <a:t/>
             </a:r>
             <a:endParaRPr sz="1350">
               <a:solidFill>
@@ -36926,7 +36935,7 @@
                 <a:cs typeface="Inter"/>
                 <a:sym typeface="Inter"/>
               </a:rPr>
-              <a:t>El cuerpo no viaja dentro de corpus.json.</a:t>
+              <a:t>El solapamiento evita perder cifras o condiciones entre cortes.</a:t>
             </a:r>
             <a:endParaRPr>
               <a:solidFill>
@@ -37127,7 +37136,7 @@
                 <a:cs typeface="Inter"/>
                 <a:sym typeface="Inter"/>
               </a:rPr>
-              <a:t>Actualizar con control</a:t>
+              <a:t>Reconstruir y evaluar con control</a:t>
             </a:r>
             <a:endParaRPr b="1" sz="2800">
               <a:solidFill>
@@ -37188,7 +37197,7 @@
                 <a:cs typeface="Inter"/>
                 <a:sym typeface="Inter"/>
               </a:rPr>
-              <a:t>Un texto sintético no puede manchar el temario.</a:t>
+              <a:t>Desde documentos en bruto e índice vacío hasta el test 14 + 6.</a:t>
             </a:r>
             <a:endParaRPr>
               <a:solidFill>
@@ -37421,7 +37430,7 @@
                 <a:cs typeface="Inter"/>
                 <a:sym typeface="Inter"/>
               </a:rPr>
-              <a:t>Aislar</a:t>
+              <a:t>Vaciar</a:t>
             </a:r>
             <a:endParaRPr b="1" sz="1700">
               <a:solidFill>
@@ -37625,7 +37634,7 @@
                 <a:cs typeface="Inter"/>
                 <a:sym typeface="Inter"/>
               </a:rPr>
-              <a:t>Etiquetar</a:t>
+              <a:t>Ingerir</a:t>
             </a:r>
             <a:endParaRPr b="1" sz="1700">
               <a:solidFill>
@@ -37829,7 +37838,7 @@
                 <a:cs typeface="Inter"/>
                 <a:sym typeface="Inter"/>
               </a:rPr>
-              <a:t>Reindexar</a:t>
+              <a:t>Validar</a:t>
             </a:r>
             <a:endParaRPr b="1" sz="1700">
               <a:solidFill>
@@ -38007,7 +38016,7 @@
                 <a:cs typeface="Inter"/>
                 <a:sym typeface="Inter"/>
               </a:rPr>
-              <a:t>Comparar</a:t>
+              <a:t>Evaluar</a:t>
             </a:r>
             <a:endParaRPr b="1" sz="1700">
               <a:solidFill>
@@ -38068,7 +38077,7 @@
                 <a:cs typeface="Inter"/>
                 <a:sym typeface="Inter"/>
               </a:rPr>
-              <a:t>La evaluación reservada no forma parte de la demo.</a:t>
+              <a:t>Validación para calibrar; 20 preguntas reservadas para medir.</a:t>
             </a:r>
             <a:endParaRPr sz="1800">
               <a:solidFill>
@@ -38129,7 +38138,7 @@
                 <a:cs typeface="Fira Code"/>
                 <a:sym typeface="Fira Code"/>
               </a:rPr>
-              <a:t>fixtures/fragmento-sintetico.json</a:t>
+              <a:t>bun run lab:rebuild &amp;&amp; bun run lab:eval</a:t>
             </a:r>
             <a:endParaRPr>
               <a:solidFill>
@@ -38404,7 +38413,7 @@
                 <a:cs typeface="Inter"/>
                 <a:sym typeface="Inter"/>
               </a:rPr>
-              <a:t>No entra en el corpus real</a:t>
+              <a:t>Lectura de vuelta</a:t>
             </a:r>
             <a:endParaRPr sz="1200">
               <a:solidFill>
@@ -38462,7 +38471,7 @@
                 <a:cs typeface="Inter"/>
                 <a:sym typeface="Inter"/>
               </a:rPr>
-              <a:t>Queda marcado como sintético</a:t>
+              <a:t>Sin reajustar con el test</a:t>
             </a:r>
             <a:endParaRPr sz="1200">
               <a:solidFill>

</xml_diff>